<commit_message>
Polish deck (native architecture, headline-to-P&L story, impact breakdown), trim docs and screenshots
</commit_message>
<xml_diff>
--- a/docs/presentation.pptx
+++ b/docs/presentation.pptx
@@ -1343,7 +1343,7 @@
           <a:lstStyle/>
           <a:p>
             <a:r>
-              <a:t>Three pain points: volume, ambiguity (tone vs impact) and the gap between text and P&amp;L. Our pipeline ingests, understands, scores and stresses, with an explanation at every step.</a:t>
+              <a:t>Three pain points: volume, ambiguity (tone vs impact) and the gap between text and P&amp;L. One real record from the bundled data: a missed coupon becomes a Credit Event signal with impact 9, which triggers the issuer-credit scenario and shows the loss on the book, including the CDS hedge.</a:t>
             </a:r>
           </a:p>
         </p:txBody>
@@ -1413,7 +1413,7 @@
           <a:lstStyle/>
           <a:p>
             <a:r>
-              <a:t>Walk the diagram left to right: sources, ingestion, NLP, signal, stress, consumers.</a:t>
+              <a:t>Top row: every record becomes a validated, explained signal. Bottom row: a high-impact signal selects a scenario that revalues the synthetic portfolio; results flow to the same dashboard, API and reports. Detailed diagram: docs/architecture.png.</a:t>
             </a:r>
           </a:p>
         </p:txBody>
@@ -5177,7 +5177,7 @@
       </p:sp>
       <p:pic>
         <p:nvPicPr>
-          <p:cNvPr id="13" name="Picture 12" descr="overview_fold.png"/>
+          <p:cNvPr id="13" name="Picture 12" descr="overview.png"/>
           <p:cNvPicPr>
             <a:picLocks noChangeAspect="1"/>
           </p:cNvPicPr>
@@ -6309,7 +6309,7 @@
                 </a:solidFill>
                 <a:latin typeface="Calibri"/>
               </a:rPr>
-              <a:t>Our approach: one explainable pipeline</a:t>
+              <a:t>Our approach: headline to P&amp;L in one pipeline</a:t>
             </a:r>
           </a:p>
         </p:txBody>
@@ -6323,7 +6323,7 @@
         <p:spPr>
           <a:xfrm>
             <a:off x="6080760" y="2011680"/>
-            <a:ext cx="5532120" cy="841248"/>
+            <a:ext cx="5532120" cy="1005840"/>
           </a:xfrm>
           <a:prstGeom prst="roundRect">
             <a:avLst>
@@ -6362,67 +6362,14 @@
       </p:sp>
       <p:sp>
         <p:nvSpPr>
-          <p:cNvPr id="19" name="Oval 18"/>
-          <p:cNvSpPr/>
-          <p:nvPr/>
-        </p:nvSpPr>
-        <p:spPr>
-          <a:xfrm>
-            <a:off x="6263640" y="2203704"/>
-            <a:ext cx="457200" cy="457200"/>
-          </a:xfrm>
-          <a:prstGeom prst="ellipse">
-            <a:avLst/>
-          </a:prstGeom>
-          <a:solidFill>
-            <a:srgbClr val="4F7CFF"/>
-          </a:solidFill>
-          <a:ln>
-            <a:noFill/>
-          </a:ln>
-          <a:effectLst/>
-        </p:spPr>
-        <p:style>
-          <a:lnRef idx="1">
-            <a:schemeClr val="accent1"/>
-          </a:lnRef>
-          <a:fillRef idx="3">
-            <a:schemeClr val="accent1"/>
-          </a:fillRef>
-          <a:effectRef idx="2">
-            <a:schemeClr val="accent1"/>
-          </a:effectRef>
-          <a:fontRef idx="minor">
-            <a:schemeClr val="lt1"/>
-          </a:fontRef>
-        </p:style>
-        <p:txBody>
-          <a:bodyPr rtlCol="0" anchor="ctr" lIns="0" rIns="0" tIns="0" bIns="0"/>
-          <a:lstStyle/>
-          <a:p>
-            <a:pPr algn="ctr"/>
-            <a:r>
-              <a:rPr sz="1400" b="1">
-                <a:solidFill>
-                  <a:srgbClr val="0B1220"/>
-                </a:solidFill>
-                <a:latin typeface="Calibri"/>
-              </a:rPr>
-              <a:t>1</a:t>
-            </a:r>
-          </a:p>
-        </p:txBody>
-      </p:sp>
-      <p:sp>
-        <p:nvSpPr>
-          <p:cNvPr id="20" name="TextBox 19"/>
+          <p:cNvPr id="19" name="TextBox 18"/>
           <p:cNvSpPr txBox="1"/>
           <p:nvPr/>
         </p:nvSpPr>
         <p:spPr>
           <a:xfrm>
-            <a:off x="6903720" y="2112264"/>
-            <a:ext cx="4480560" cy="320040"/>
+            <a:off x="6263640" y="2103120"/>
+            <a:ext cx="5212080" cy="274320"/>
           </a:xfrm>
           <a:prstGeom prst="rect">
             <a:avLst/>
@@ -6441,27 +6388,27 @@
               </a:spcAft>
             </a:pPr>
             <a:r>
-              <a:rPr sz="1500" b="1" i="0">
-                <a:solidFill>
-                  <a:srgbClr val="F3F6FC"/>
-                </a:solidFill>
-                <a:latin typeface="Calibri"/>
-              </a:rPr>
-              <a:t>Ingest</a:t>
-            </a:r>
-          </a:p>
-        </p:txBody>
-      </p:sp>
-      <p:sp>
-        <p:nvSpPr>
-          <p:cNvPr id="21" name="TextBox 20"/>
+              <a:rPr sz="1050" b="1" i="0">
+                <a:solidFill>
+                  <a:srgbClr val="4F7CFF"/>
+                </a:solidFill>
+                <a:latin typeface="Calibri"/>
+              </a:rPr>
+              <a:t>1  RAW TEXT  ·  news-like record</a:t>
+            </a:r>
+          </a:p>
+        </p:txBody>
+      </p:sp>
+      <p:sp>
+        <p:nvSpPr>
+          <p:cNvPr id="20" name="TextBox 19"/>
           <p:cNvSpPr txBox="1"/>
           <p:nvPr/>
         </p:nvSpPr>
         <p:spPr>
           <a:xfrm>
-            <a:off x="6903720" y="2423160"/>
-            <a:ext cx="4572000" cy="411480"/>
+            <a:off x="6263640" y="2395728"/>
+            <a:ext cx="5212080" cy="548640"/>
           </a:xfrm>
           <a:prstGeom prst="rect">
             <a:avLst/>
@@ -6480,17 +6427,53 @@
               </a:spcAft>
             </a:pPr>
             <a:r>
-              <a:rPr sz="1250" b="0" i="0">
-                <a:solidFill>
-                  <a:srgbClr val="94A3B8"/>
-                </a:solidFill>
-                <a:latin typeface="Calibri"/>
-              </a:rPr>
-              <a:t>News + social adapters, validation, dedupe, stable IDs</a:t>
-            </a:r>
-          </a:p>
-        </p:txBody>
-      </p:sp>
+              <a:rPr sz="1300" b="0" i="1">
+                <a:solidFill>
+                  <a:srgbClr val="F3F6FC"/>
+                </a:solidFill>
+                <a:latin typeface="Calibri"/>
+              </a:rPr>
+              <a:t>“Meridian Shipping missed a coupon payment on its senior bonds”</a:t>
+            </a:r>
+          </a:p>
+        </p:txBody>
+      </p:sp>
+      <p:cxnSp>
+        <p:nvCxnSpPr>
+          <p:cNvPr id="21" name="Connector 20"/>
+          <p:cNvCxnSpPr/>
+          <p:nvPr/>
+        </p:nvCxnSpPr>
+        <p:spPr>
+          <a:xfrm>
+            <a:off x="8846820" y="3035808"/>
+            <a:ext cx="0" cy="329184"/>
+          </a:xfrm>
+          <a:prstGeom prst="line">
+            <a:avLst/>
+          </a:prstGeom>
+          <a:ln w="22225">
+            <a:solidFill>
+              <a:srgbClr val="4F7CFF"/>
+            </a:solidFill>
+            <a:tailEnd type="triangle"/>
+          </a:ln>
+        </p:spPr>
+        <p:style>
+          <a:lnRef idx="2">
+            <a:schemeClr val="accent1"/>
+          </a:lnRef>
+          <a:fillRef idx="0">
+            <a:schemeClr val="accent1"/>
+          </a:fillRef>
+          <a:effectRef idx="1">
+            <a:schemeClr val="accent1"/>
+          </a:effectRef>
+          <a:fontRef idx="minor">
+            <a:schemeClr val="tx1"/>
+          </a:fontRef>
+        </p:style>
+      </p:cxnSp>
       <p:sp>
         <p:nvSpPr>
           <p:cNvPr id="22" name="Rounded Rectangle 21"/>
@@ -6499,8 +6482,8 @@
         </p:nvSpPr>
         <p:spPr>
           <a:xfrm>
-            <a:off x="6080760" y="2990088"/>
-            <a:ext cx="5532120" cy="841248"/>
+            <a:off x="6080760" y="3383280"/>
+            <a:ext cx="5532120" cy="1143000"/>
           </a:xfrm>
           <a:prstGeom prst="roundRect">
             <a:avLst>
@@ -6539,23 +6522,66 @@
       </p:sp>
       <p:sp>
         <p:nvSpPr>
-          <p:cNvPr id="23" name="Oval 22"/>
+          <p:cNvPr id="23" name="TextBox 22"/>
+          <p:cNvSpPr txBox="1"/>
+          <p:nvPr/>
+        </p:nvSpPr>
+        <p:spPr>
+          <a:xfrm>
+            <a:off x="6263640" y="3474720"/>
+            <a:ext cx="5212080" cy="274320"/>
+          </a:xfrm>
+          <a:prstGeom prst="rect">
+            <a:avLst/>
+          </a:prstGeom>
+          <a:noFill/>
+        </p:spPr>
+        <p:txBody>
+          <a:bodyPr wrap="square" lIns="0" rIns="0" tIns="0" bIns="0" anchor="t">
+            <a:spAutoFit/>
+          </a:bodyPr>
+          <a:lstStyle/>
+          <a:p>
+            <a:pPr algn="l">
+              <a:spcAft>
+                <a:spcPts val="400"/>
+              </a:spcAft>
+            </a:pPr>
+            <a:r>
+              <a:rPr sz="1050" b="1" i="0">
+                <a:solidFill>
+                  <a:srgbClr val="F4B942"/>
+                </a:solidFill>
+                <a:latin typeface="Calibri"/>
+              </a:rPr>
+              <a:t>2  STRUCTURED SIGNAL  ·  NLP engine + explanation</a:t>
+            </a:r>
+          </a:p>
+        </p:txBody>
+      </p:sp>
+      <p:sp>
+        <p:nvSpPr>
+          <p:cNvPr id="24" name="Rounded Rectangle 23"/>
           <p:cNvSpPr/>
           <p:nvPr/>
         </p:nvSpPr>
         <p:spPr>
           <a:xfrm>
-            <a:off x="6263640" y="3182112"/>
-            <a:ext cx="457200" cy="457200"/>
-          </a:xfrm>
-          <a:prstGeom prst="ellipse">
-            <a:avLst/>
+            <a:off x="6263640" y="3840480"/>
+            <a:ext cx="1188720" cy="292608"/>
+          </a:xfrm>
+          <a:prstGeom prst="roundRect">
+            <a:avLst>
+              <a:gd name="adj" fmla="val 50000"/>
+            </a:avLst>
           </a:prstGeom>
           <a:solidFill>
-            <a:srgbClr val="4F7CFF"/>
+            <a:srgbClr val="111B2E"/>
           </a:solidFill>
-          <a:ln>
-            <a:noFill/>
+          <a:ln w="12700">
+            <a:solidFill>
+              <a:srgbClr val="4F7CFF"/>
+            </a:solidFill>
           </a:ln>
           <a:effectLst/>
         </p:spPr>
@@ -6574,32 +6600,203 @@
           </a:fontRef>
         </p:style>
         <p:txBody>
-          <a:bodyPr rtlCol="0" anchor="ctr" lIns="0" rIns="0" tIns="0" bIns="0"/>
+          <a:bodyPr rtlCol="0" anchor="ctr" lIns="45720" rIns="45720" tIns="0" bIns="0"/>
           <a:lstStyle/>
           <a:p>
             <a:pPr algn="ctr"/>
             <a:r>
-              <a:rPr sz="1400" b="1">
-                <a:solidFill>
-                  <a:srgbClr val="0B1220"/>
-                </a:solidFill>
-                <a:latin typeface="Calibri"/>
-              </a:rPr>
-              <a:t>2</a:t>
-            </a:r>
-          </a:p>
-        </p:txBody>
-      </p:sp>
-      <p:sp>
-        <p:nvSpPr>
-          <p:cNvPr id="24" name="TextBox 23"/>
+              <a:rPr sz="1050" b="1">
+                <a:solidFill>
+                  <a:srgbClr val="4F7CFF"/>
+                </a:solidFill>
+                <a:latin typeface="Calibri"/>
+              </a:rPr>
+              <a:t>Credit Event</a:t>
+            </a:r>
+          </a:p>
+        </p:txBody>
+      </p:sp>
+      <p:sp>
+        <p:nvSpPr>
+          <p:cNvPr id="25" name="Rounded Rectangle 24"/>
+          <p:cNvSpPr/>
+          <p:nvPr/>
+        </p:nvSpPr>
+        <p:spPr>
+          <a:xfrm>
+            <a:off x="7525512" y="3840480"/>
+            <a:ext cx="1325880" cy="292608"/>
+          </a:xfrm>
+          <a:prstGeom prst="roundRect">
+            <a:avLst>
+              <a:gd name="adj" fmla="val 50000"/>
+            </a:avLst>
+          </a:prstGeom>
+          <a:solidFill>
+            <a:srgbClr val="111B2E"/>
+          </a:solidFill>
+          <a:ln w="12700">
+            <a:solidFill>
+              <a:srgbClr val="F05260"/>
+            </a:solidFill>
+          </a:ln>
+          <a:effectLst/>
+        </p:spPr>
+        <p:style>
+          <a:lnRef idx="1">
+            <a:schemeClr val="accent1"/>
+          </a:lnRef>
+          <a:fillRef idx="3">
+            <a:schemeClr val="accent1"/>
+          </a:fillRef>
+          <a:effectRef idx="2">
+            <a:schemeClr val="accent1"/>
+          </a:effectRef>
+          <a:fontRef idx="minor">
+            <a:schemeClr val="lt1"/>
+          </a:fontRef>
+        </p:style>
+        <p:txBody>
+          <a:bodyPr rtlCol="0" anchor="ctr" lIns="45720" rIns="45720" tIns="0" bIns="0"/>
+          <a:lstStyle/>
+          <a:p>
+            <a:pPr algn="ctr"/>
+            <a:r>
+              <a:rPr sz="1050" b="1">
+                <a:solidFill>
+                  <a:srgbClr val="F05260"/>
+                </a:solidFill>
+                <a:latin typeface="Calibri"/>
+              </a:rPr>
+              <a:t>Sentiment -1.00</a:t>
+            </a:r>
+          </a:p>
+        </p:txBody>
+      </p:sp>
+      <p:sp>
+        <p:nvSpPr>
+          <p:cNvPr id="26" name="Rounded Rectangle 25"/>
+          <p:cNvSpPr/>
+          <p:nvPr/>
+        </p:nvSpPr>
+        <p:spPr>
+          <a:xfrm>
+            <a:off x="8924544" y="3840480"/>
+            <a:ext cx="1051560" cy="292608"/>
+          </a:xfrm>
+          <a:prstGeom prst="roundRect">
+            <a:avLst>
+              <a:gd name="adj" fmla="val 50000"/>
+            </a:avLst>
+          </a:prstGeom>
+          <a:solidFill>
+            <a:srgbClr val="111B2E"/>
+          </a:solidFill>
+          <a:ln w="12700">
+            <a:solidFill>
+              <a:srgbClr val="F05260"/>
+            </a:solidFill>
+          </a:ln>
+          <a:effectLst/>
+        </p:spPr>
+        <p:style>
+          <a:lnRef idx="1">
+            <a:schemeClr val="accent1"/>
+          </a:lnRef>
+          <a:fillRef idx="3">
+            <a:schemeClr val="accent1"/>
+          </a:fillRef>
+          <a:effectRef idx="2">
+            <a:schemeClr val="accent1"/>
+          </a:effectRef>
+          <a:fontRef idx="minor">
+            <a:schemeClr val="lt1"/>
+          </a:fontRef>
+        </p:style>
+        <p:txBody>
+          <a:bodyPr rtlCol="0" anchor="ctr" lIns="45720" rIns="45720" tIns="0" bIns="0"/>
+          <a:lstStyle/>
+          <a:p>
+            <a:pPr algn="ctr"/>
+            <a:r>
+              <a:rPr sz="1050" b="1">
+                <a:solidFill>
+                  <a:srgbClr val="F05260"/>
+                </a:solidFill>
+                <a:latin typeface="Calibri"/>
+              </a:rPr>
+              <a:t>Impact 9/10</a:t>
+            </a:r>
+          </a:p>
+        </p:txBody>
+      </p:sp>
+      <p:sp>
+        <p:nvSpPr>
+          <p:cNvPr id="27" name="Rounded Rectangle 26"/>
+          <p:cNvSpPr/>
+          <p:nvPr/>
+        </p:nvSpPr>
+        <p:spPr>
+          <a:xfrm>
+            <a:off x="10049256" y="3840480"/>
+            <a:ext cx="1417320" cy="292608"/>
+          </a:xfrm>
+          <a:prstGeom prst="roundRect">
+            <a:avLst>
+              <a:gd name="adj" fmla="val 50000"/>
+            </a:avLst>
+          </a:prstGeom>
+          <a:solidFill>
+            <a:srgbClr val="111B2E"/>
+          </a:solidFill>
+          <a:ln w="12700">
+            <a:solidFill>
+              <a:srgbClr val="F3F6FC"/>
+            </a:solidFill>
+          </a:ln>
+          <a:effectLst/>
+        </p:spPr>
+        <p:style>
+          <a:lnRef idx="1">
+            <a:schemeClr val="accent1"/>
+          </a:lnRef>
+          <a:fillRef idx="3">
+            <a:schemeClr val="accent1"/>
+          </a:fillRef>
+          <a:effectRef idx="2">
+            <a:schemeClr val="accent1"/>
+          </a:effectRef>
+          <a:fontRef idx="minor">
+            <a:schemeClr val="lt1"/>
+          </a:fontRef>
+        </p:style>
+        <p:txBody>
+          <a:bodyPr rtlCol="0" anchor="ctr" lIns="45720" rIns="45720" tIns="0" bIns="0"/>
+          <a:lstStyle/>
+          <a:p>
+            <a:pPr algn="ctr"/>
+            <a:r>
+              <a:rPr sz="1050" b="1">
+                <a:solidFill>
+                  <a:srgbClr val="F3F6FC"/>
+                </a:solidFill>
+                <a:latin typeface="Calibri"/>
+              </a:rPr>
+              <a:t>MRDS · conf 1.00</a:t>
+            </a:r>
+          </a:p>
+        </p:txBody>
+      </p:sp>
+      <p:sp>
+        <p:nvSpPr>
+          <p:cNvPr id="28" name="TextBox 27"/>
           <p:cNvSpPr txBox="1"/>
           <p:nvPr/>
         </p:nvSpPr>
         <p:spPr>
           <a:xfrm>
-            <a:off x="6903720" y="3090672"/>
-            <a:ext cx="4480560" cy="320040"/>
+            <a:off x="6263640" y="4206240"/>
+            <a:ext cx="5212080" cy="274320"/>
           </a:xfrm>
           <a:prstGeom prst="rect">
             <a:avLst/>
@@ -6618,66 +6815,63 @@
               </a:spcAft>
             </a:pPr>
             <a:r>
-              <a:rPr sz="1500" b="1" i="0">
-                <a:solidFill>
-                  <a:srgbClr val="F3F6FC"/>
-                </a:solidFill>
-                <a:latin typeface="Calibri"/>
-              </a:rPr>
-              <a:t>Understand</a:t>
-            </a:r>
-          </a:p>
-        </p:txBody>
-      </p:sp>
-      <p:sp>
-        <p:nvSpPr>
-          <p:cNvPr id="25" name="TextBox 24"/>
-          <p:cNvSpPr txBox="1"/>
-          <p:nvPr/>
-        </p:nvSpPr>
-        <p:spPr>
-          <a:xfrm>
-            <a:off x="6903720" y="3401568"/>
-            <a:ext cx="4572000" cy="411480"/>
-          </a:xfrm>
-          <a:prstGeom prst="rect">
-            <a:avLst/>
-          </a:prstGeom>
-          <a:noFill/>
-        </p:spPr>
-        <p:txBody>
-          <a:bodyPr wrap="square" lIns="0" rIns="0" tIns="0" bIns="0" anchor="t">
-            <a:spAutoFit/>
-          </a:bodyPr>
-          <a:lstStyle/>
-          <a:p>
-            <a:pPr algn="l">
-              <a:spcAft>
-                <a:spcPts val="400"/>
-              </a:spcAft>
-            </a:pPr>
-            <a:r>
-              <a:rPr sz="1250" b="0" i="0">
+              <a:rPr sz="1100" b="0" i="0">
                 <a:solidFill>
                   <a:srgbClr val="94A3B8"/>
                 </a:solidFill>
                 <a:latin typeface="Calibri"/>
               </a:rPr>
-              <a:t>Entities &amp; tickers, finance-tuned sentiment, 10 event types</a:t>
-            </a:r>
-          </a:p>
-        </p:txBody>
-      </p:sp>
-      <p:sp>
-        <p:nvSpPr>
-          <p:cNvPr id="26" name="Rounded Rectangle 25"/>
+              <a:t>impact &gt; 7  -&gt;  stress test triggered automatically</a:t>
+            </a:r>
+          </a:p>
+        </p:txBody>
+      </p:sp>
+      <p:cxnSp>
+        <p:nvCxnSpPr>
+          <p:cNvPr id="29" name="Connector 28"/>
+          <p:cNvCxnSpPr/>
+          <p:nvPr/>
+        </p:nvCxnSpPr>
+        <p:spPr>
+          <a:xfrm>
+            <a:off x="8846820" y="4544568"/>
+            <a:ext cx="0" cy="329184"/>
+          </a:xfrm>
+          <a:prstGeom prst="line">
+            <a:avLst/>
+          </a:prstGeom>
+          <a:ln w="22225">
+            <a:solidFill>
+              <a:srgbClr val="4F7CFF"/>
+            </a:solidFill>
+            <a:tailEnd type="triangle"/>
+          </a:ln>
+        </p:spPr>
+        <p:style>
+          <a:lnRef idx="2">
+            <a:schemeClr val="accent1"/>
+          </a:lnRef>
+          <a:fillRef idx="0">
+            <a:schemeClr val="accent1"/>
+          </a:fillRef>
+          <a:effectRef idx="1">
+            <a:schemeClr val="accent1"/>
+          </a:effectRef>
+          <a:fontRef idx="minor">
+            <a:schemeClr val="tx1"/>
+          </a:fontRef>
+        </p:style>
+      </p:cxnSp>
+      <p:sp>
+        <p:nvSpPr>
+          <p:cNvPr id="30" name="Rounded Rectangle 29"/>
           <p:cNvSpPr/>
           <p:nvPr/>
         </p:nvSpPr>
         <p:spPr>
           <a:xfrm>
-            <a:off x="6080760" y="3968496"/>
-            <a:ext cx="5532120" cy="841248"/>
+            <a:off x="6080760" y="4892040"/>
+            <a:ext cx="5532120" cy="1143000"/>
           </a:xfrm>
           <a:prstGeom prst="roundRect">
             <a:avLst>
@@ -6716,67 +6910,14 @@
       </p:sp>
       <p:sp>
         <p:nvSpPr>
-          <p:cNvPr id="27" name="Oval 26"/>
-          <p:cNvSpPr/>
-          <p:nvPr/>
-        </p:nvSpPr>
-        <p:spPr>
-          <a:xfrm>
-            <a:off x="6263640" y="4160520"/>
-            <a:ext cx="457200" cy="457200"/>
-          </a:xfrm>
-          <a:prstGeom prst="ellipse">
-            <a:avLst/>
-          </a:prstGeom>
-          <a:solidFill>
-            <a:srgbClr val="F4B942"/>
-          </a:solidFill>
-          <a:ln>
-            <a:noFill/>
-          </a:ln>
-          <a:effectLst/>
-        </p:spPr>
-        <p:style>
-          <a:lnRef idx="1">
-            <a:schemeClr val="accent1"/>
-          </a:lnRef>
-          <a:fillRef idx="3">
-            <a:schemeClr val="accent1"/>
-          </a:fillRef>
-          <a:effectRef idx="2">
-            <a:schemeClr val="accent1"/>
-          </a:effectRef>
-          <a:fontRef idx="minor">
-            <a:schemeClr val="lt1"/>
-          </a:fontRef>
-        </p:style>
-        <p:txBody>
-          <a:bodyPr rtlCol="0" anchor="ctr" lIns="0" rIns="0" tIns="0" bIns="0"/>
-          <a:lstStyle/>
-          <a:p>
-            <a:pPr algn="ctr"/>
-            <a:r>
-              <a:rPr sz="1400" b="1">
-                <a:solidFill>
-                  <a:srgbClr val="0B1220"/>
-                </a:solidFill>
-                <a:latin typeface="Calibri"/>
-              </a:rPr>
-              <a:t>3</a:t>
-            </a:r>
-          </a:p>
-        </p:txBody>
-      </p:sp>
-      <p:sp>
-        <p:nvSpPr>
-          <p:cNvPr id="28" name="TextBox 27"/>
+          <p:cNvPr id="31" name="TextBox 30"/>
           <p:cNvSpPr txBox="1"/>
           <p:nvPr/>
         </p:nvSpPr>
         <p:spPr>
           <a:xfrm>
-            <a:off x="6903720" y="4069080"/>
-            <a:ext cx="4480560" cy="320040"/>
+            <a:off x="6263640" y="4983480"/>
+            <a:ext cx="5212080" cy="274320"/>
           </a:xfrm>
           <a:prstGeom prst="rect">
             <a:avLst/>
@@ -6795,27 +6936,27 @@
               </a:spcAft>
             </a:pPr>
             <a:r>
-              <a:rPr sz="1500" b="1" i="0">
-                <a:solidFill>
-                  <a:srgbClr val="F3F6FC"/>
-                </a:solidFill>
-                <a:latin typeface="Calibri"/>
-              </a:rPr>
-              <a:t>Score</a:t>
-            </a:r>
-          </a:p>
-        </p:txBody>
-      </p:sp>
-      <p:sp>
-        <p:nvSpPr>
-          <p:cNvPr id="29" name="TextBox 28"/>
+              <a:rPr sz="1050" b="1" i="0">
+                <a:solidFill>
+                  <a:srgbClr val="18A999"/>
+                </a:solidFill>
+                <a:latin typeface="Calibri"/>
+              </a:rPr>
+              <a:t>3  PORTFOLIO IMPACT  ·  issuer credit event</a:t>
+            </a:r>
+          </a:p>
+        </p:txBody>
+      </p:sp>
+      <p:sp>
+        <p:nvSpPr>
+          <p:cNvPr id="32" name="TextBox 31"/>
           <p:cNvSpPr txBox="1"/>
           <p:nvPr/>
         </p:nvSpPr>
         <p:spPr>
           <a:xfrm>
-            <a:off x="6903720" y="4379976"/>
-            <a:ext cx="4572000" cy="411480"/>
+            <a:off x="6263640" y="5285232"/>
+            <a:ext cx="5212080" cy="685800"/>
           </a:xfrm>
           <a:prstGeom prst="rect">
             <a:avLst/>
@@ -6834,137 +6975,24 @@
               </a:spcAft>
             </a:pPr>
             <a:r>
-              <a:rPr sz="1250" b="0" i="0">
+              <a:rPr sz="1800" b="1" i="0">
+                <a:solidFill>
+                  <a:srgbClr val="F05260"/>
+                </a:solidFill>
+                <a:latin typeface="Calibri"/>
+              </a:rPr>
+              <a:t>-$12.47m (-1.22%)</a:t>
+            </a:r>
+            <a:r>
+              <a:rPr sz="1200" b="0" i="0">
                 <a:solidFill>
                   <a:srgbClr val="94A3B8"/>
                 </a:solidFill>
                 <a:latin typeface="Calibri"/>
               </a:rPr>
-              <a:t>Impact 1-10 from transparent, configurable factors + explanation</a:t>
-            </a:r>
-          </a:p>
-        </p:txBody>
-      </p:sp>
-      <p:sp>
-        <p:nvSpPr>
-          <p:cNvPr id="30" name="Rounded Rectangle 29"/>
-          <p:cNvSpPr/>
-          <p:nvPr/>
-        </p:nvSpPr>
-        <p:spPr>
-          <a:xfrm>
-            <a:off x="6080760" y="4946904"/>
-            <a:ext cx="5532120" cy="841248"/>
-          </a:xfrm>
-          <a:prstGeom prst="roundRect">
-            <a:avLst>
-              <a:gd name="adj" fmla="val 6000"/>
-            </a:avLst>
-          </a:prstGeom>
-          <a:solidFill>
-            <a:srgbClr val="18263B"/>
-          </a:solidFill>
-          <a:ln w="12700">
-            <a:solidFill>
-              <a:srgbClr val="2B3A50"/>
-            </a:solidFill>
-          </a:ln>
-          <a:effectLst/>
-        </p:spPr>
-        <p:style>
-          <a:lnRef idx="1">
-            <a:schemeClr val="accent1"/>
-          </a:lnRef>
-          <a:fillRef idx="3">
-            <a:schemeClr val="accent1"/>
-          </a:fillRef>
-          <a:effectRef idx="2">
-            <a:schemeClr val="accent1"/>
-          </a:effectRef>
-          <a:fontRef idx="minor">
-            <a:schemeClr val="lt1"/>
-          </a:fontRef>
-        </p:style>
-        <p:txBody>
-          <a:bodyPr rtlCol="0" anchor="ctr"/>
-          <a:lstStyle/>
-          <a:p/>
-        </p:txBody>
-      </p:sp>
-      <p:sp>
-        <p:nvSpPr>
-          <p:cNvPr id="31" name="Oval 30"/>
-          <p:cNvSpPr/>
-          <p:nvPr/>
-        </p:nvSpPr>
-        <p:spPr>
-          <a:xfrm>
-            <a:off x="6263640" y="5138928"/>
-            <a:ext cx="457200" cy="457200"/>
-          </a:xfrm>
-          <a:prstGeom prst="ellipse">
-            <a:avLst/>
-          </a:prstGeom>
-          <a:solidFill>
-            <a:srgbClr val="18A999"/>
-          </a:solidFill>
-          <a:ln>
-            <a:noFill/>
-          </a:ln>
-          <a:effectLst/>
-        </p:spPr>
-        <p:style>
-          <a:lnRef idx="1">
-            <a:schemeClr val="accent1"/>
-          </a:lnRef>
-          <a:fillRef idx="3">
-            <a:schemeClr val="accent1"/>
-          </a:fillRef>
-          <a:effectRef idx="2">
-            <a:schemeClr val="accent1"/>
-          </a:effectRef>
-          <a:fontRef idx="minor">
-            <a:schemeClr val="lt1"/>
-          </a:fontRef>
-        </p:style>
-        <p:txBody>
-          <a:bodyPr rtlCol="0" anchor="ctr" lIns="0" rIns="0" tIns="0" bIns="0"/>
-          <a:lstStyle/>
-          <a:p>
-            <a:pPr algn="ctr"/>
-            <a:r>
-              <a:rPr sz="1400" b="1">
-                <a:solidFill>
-                  <a:srgbClr val="0B1220"/>
-                </a:solidFill>
-                <a:latin typeface="Calibri"/>
-              </a:rPr>
-              <a:t>4</a:t>
-            </a:r>
-          </a:p>
-        </p:txBody>
-      </p:sp>
-      <p:sp>
-        <p:nvSpPr>
-          <p:cNvPr id="32" name="TextBox 31"/>
-          <p:cNvSpPr txBox="1"/>
-          <p:nvPr/>
-        </p:nvSpPr>
-        <p:spPr>
-          <a:xfrm>
-            <a:off x="6903720" y="5047488"/>
-            <a:ext cx="4480560" cy="320040"/>
-          </a:xfrm>
-          <a:prstGeom prst="rect">
-            <a:avLst/>
-          </a:prstGeom>
-          <a:noFill/>
-        </p:spPr>
-        <p:txBody>
-          <a:bodyPr wrap="square" lIns="0" rIns="0" tIns="0" bIns="0" anchor="t">
-            <a:spAutoFit/>
-          </a:bodyPr>
-          <a:lstStyle/>
+              <a:t>   on $1.02bn</a:t>
+            </a:r>
+          </a:p>
           <a:p>
             <a:pPr algn="l">
               <a:spcAft>
@@ -6972,91 +7000,13 @@
               </a:spcAft>
             </a:pPr>
             <a:r>
-              <a:rPr sz="1500" b="1" i="0">
-                <a:solidFill>
-                  <a:srgbClr val="F3F6FC"/>
-                </a:solidFill>
-                <a:latin typeface="Calibri"/>
-              </a:rPr>
-              <a:t>Stress</a:t>
-            </a:r>
-          </a:p>
-        </p:txBody>
-      </p:sp>
-      <p:sp>
-        <p:nvSpPr>
-          <p:cNvPr id="33" name="TextBox 32"/>
-          <p:cNvSpPr txBox="1"/>
-          <p:nvPr/>
-        </p:nvSpPr>
-        <p:spPr>
-          <a:xfrm>
-            <a:off x="6903720" y="5358384"/>
-            <a:ext cx="4572000" cy="411480"/>
-          </a:xfrm>
-          <a:prstGeom prst="rect">
-            <a:avLst/>
-          </a:prstGeom>
-          <a:noFill/>
-        </p:spPr>
-        <p:txBody>
-          <a:bodyPr wrap="square" lIns="0" rIns="0" tIns="0" bIns="0" anchor="t">
-            <a:spAutoFit/>
-          </a:bodyPr>
-          <a:lstStyle/>
-          <a:p>
-            <a:pPr algn="l">
-              <a:spcAft>
-                <a:spcPts val="400"/>
-              </a:spcAft>
-            </a:pPr>
-            <a:r>
-              <a:rPr sz="1250" b="0" i="0">
+              <a:rPr sz="1100" b="0" i="0">
                 <a:solidFill>
                   <a:srgbClr val="94A3B8"/>
                 </a:solidFill>
                 <a:latin typeface="Calibri"/>
               </a:rPr>
-              <a:t>Impact &gt; 7 auto-selects a scenario and revalues a 37-position book</a:t>
-            </a:r>
-          </a:p>
-        </p:txBody>
-      </p:sp>
-      <p:sp>
-        <p:nvSpPr>
-          <p:cNvPr id="34" name="TextBox 33"/>
-          <p:cNvSpPr txBox="1"/>
-          <p:nvPr/>
-        </p:nvSpPr>
-        <p:spPr>
-          <a:xfrm>
-            <a:off x="6080760" y="5943600"/>
-            <a:ext cx="5532120" cy="274320"/>
-          </a:xfrm>
-          <a:prstGeom prst="rect">
-            <a:avLst/>
-          </a:prstGeom>
-          <a:noFill/>
-        </p:spPr>
-        <p:txBody>
-          <a:bodyPr wrap="square" lIns="0" rIns="0" tIns="0" bIns="0" anchor="t">
-            <a:spAutoFit/>
-          </a:bodyPr>
-          <a:lstStyle/>
-          <a:p>
-            <a:pPr algn="l">
-              <a:spcAft>
-                <a:spcPts val="400"/>
-              </a:spcAft>
-            </a:pPr>
-            <a:r>
-              <a:rPr sz="1200" b="1" i="0">
-                <a:solidFill>
-                  <a:srgbClr val="18A999"/>
-                </a:solidFill>
-                <a:latin typeface="Calibri"/>
-              </a:rPr>
-              <a:t>Outputs: dashboard · REST API · JSON / CSV · printable report</a:t>
+              <a:t>worst hits: Meridian Shipping bond, loan, equity  ·  CDS hedge +$3.26m</a:t>
             </a:r>
           </a:p>
         </p:txBody>
@@ -7243,35 +7193,45 @@
           </a:p>
         </p:txBody>
       </p:sp>
-      <p:pic>
-        <p:nvPicPr>
-          <p:cNvPr id="6" name="Picture 5" descr="architecture.png"/>
-          <p:cNvPicPr>
-            <a:picLocks noChangeAspect="1"/>
-          </p:cNvPicPr>
-          <p:nvPr/>
-        </p:nvPicPr>
-        <p:blipFill>
-          <a:blip r:embed="rId2"/>
-          <a:stretch>
-            <a:fillRect/>
-          </a:stretch>
-        </p:blipFill>
-        <p:spPr>
-          <a:xfrm>
-            <a:off x="548640" y="1371600"/>
-            <a:ext cx="8183879" cy="4603432"/>
-          </a:xfrm>
-          <a:prstGeom prst="rect">
-            <a:avLst/>
-          </a:prstGeom>
-          <a:ln w="12700">
-            <a:solidFill>
-              <a:srgbClr val="2B3A50"/>
-            </a:solidFill>
-          </a:ln>
-        </p:spPr>
-      </p:pic>
+      <p:sp>
+        <p:nvSpPr>
+          <p:cNvPr id="6" name="TextBox 5"/>
+          <p:cNvSpPr txBox="1"/>
+          <p:nvPr/>
+        </p:nvSpPr>
+        <p:spPr>
+          <a:xfrm>
+            <a:off x="548640" y="1325880"/>
+            <a:ext cx="5486400" cy="274320"/>
+          </a:xfrm>
+          <a:prstGeom prst="rect">
+            <a:avLst/>
+          </a:prstGeom>
+          <a:noFill/>
+        </p:spPr>
+        <p:txBody>
+          <a:bodyPr wrap="square" lIns="0" rIns="0" tIns="0" bIns="0" anchor="t">
+            <a:spAutoFit/>
+          </a:bodyPr>
+          <a:lstStyle/>
+          <a:p>
+            <a:pPr algn="l">
+              <a:spcAft>
+                <a:spcPts val="400"/>
+              </a:spcAft>
+            </a:pPr>
+            <a:r>
+              <a:rPr sz="1050" b="1" i="0">
+                <a:solidFill>
+                  <a:srgbClr val="4F7CFF"/>
+                </a:solidFill>
+                <a:latin typeface="Calibri"/>
+              </a:rPr>
+              <a:t>SIGNAL PATH  ·  AI/NLP risk engine</a:t>
+            </a:r>
+          </a:p>
+        </p:txBody>
+      </p:sp>
       <p:sp>
         <p:nvSpPr>
           <p:cNvPr id="7" name="Rounded Rectangle 6"/>
@@ -7280,8 +7240,8 @@
         </p:nvSpPr>
         <p:spPr>
           <a:xfrm>
-            <a:off x="8961120" y="1371600"/>
-            <a:ext cx="2697480" cy="4617720"/>
+            <a:off x="548640" y="1627632"/>
+            <a:ext cx="2011680" cy="1325880"/>
           </a:xfrm>
           <a:prstGeom prst="roundRect">
             <a:avLst>
@@ -7326,8 +7286,8 @@
         </p:nvSpPr>
         <p:spPr>
           <a:xfrm>
-            <a:off x="9144000" y="1536192"/>
-            <a:ext cx="2377440" cy="365760"/>
+            <a:off x="685800" y="1755648"/>
+            <a:ext cx="1737360" cy="320040"/>
           </a:xfrm>
           <a:prstGeom prst="rect">
             <a:avLst/>
@@ -7346,13 +7306,13 @@
               </a:spcAft>
             </a:pPr>
             <a:r>
-              <a:rPr sz="1600" b="1" i="0">
+              <a:rPr sz="1400" b="1" i="0">
                 <a:solidFill>
                   <a:srgbClr val="F3F6FC"/>
                 </a:solidFill>
                 <a:latin typeface="Calibri"/>
               </a:rPr>
-              <a:t>Tech choices</a:t>
+              <a:t>Sources</a:t>
             </a:r>
           </a:p>
         </p:txBody>
@@ -7365,8 +7325,8 @@
         </p:nvSpPr>
         <p:spPr>
           <a:xfrm>
-            <a:off x="9144000" y="2011680"/>
-            <a:ext cx="2377440" cy="457200"/>
+            <a:off x="685800" y="2103120"/>
+            <a:ext cx="1737360" cy="777240"/>
           </a:xfrm>
           <a:prstGeom prst="rect">
             <a:avLst/>
@@ -7385,43 +7345,74 @@
               </a:spcAft>
             </a:pPr>
             <a:r>
-              <a:rPr sz="1200" b="1" i="0">
-                <a:solidFill>
-                  <a:srgbClr val="F3F6FC"/>
-                </a:solidFill>
-                <a:latin typeface="Calibri"/>
-              </a:rPr>
-              <a:t>Python 3.11</a:t>
-            </a:r>
-          </a:p>
-          <a:p>
-            <a:pPr algn="l">
-              <a:spcAft>
-                <a:spcPts val="400"/>
-              </a:spcAft>
-            </a:pPr>
-            <a:r>
-              <a:rPr sz="1050" b="0" i="0">
+              <a:rPr sz="1100" b="0" i="0">
                 <a:solidFill>
                   <a:srgbClr val="94A3B8"/>
                 </a:solidFill>
                 <a:latin typeface="Calibri"/>
               </a:rPr>
-              <a:t>pandas, NumPy</a:t>
-            </a:r>
-          </a:p>
-        </p:txBody>
-      </p:sp>
-      <p:sp>
-        <p:nvSpPr>
-          <p:cNvPr id="10" name="TextBox 9"/>
+              <a:t>News + social CSV / JSON
+upload · RSS (optional)</a:t>
+            </a:r>
+          </a:p>
+        </p:txBody>
+      </p:sp>
+      <p:sp>
+        <p:nvSpPr>
+          <p:cNvPr id="10" name="Rounded Rectangle 9"/>
+          <p:cNvSpPr/>
+          <p:nvPr/>
+        </p:nvSpPr>
+        <p:spPr>
+          <a:xfrm>
+            <a:off x="2788920" y="1627632"/>
+            <a:ext cx="2011680" cy="1325880"/>
+          </a:xfrm>
+          <a:prstGeom prst="roundRect">
+            <a:avLst>
+              <a:gd name="adj" fmla="val 6000"/>
+            </a:avLst>
+          </a:prstGeom>
+          <a:solidFill>
+            <a:srgbClr val="18263B"/>
+          </a:solidFill>
+          <a:ln w="12700">
+            <a:solidFill>
+              <a:srgbClr val="4F7CFF"/>
+            </a:solidFill>
+          </a:ln>
+          <a:effectLst/>
+        </p:spPr>
+        <p:style>
+          <a:lnRef idx="1">
+            <a:schemeClr val="accent1"/>
+          </a:lnRef>
+          <a:fillRef idx="3">
+            <a:schemeClr val="accent1"/>
+          </a:fillRef>
+          <a:effectRef idx="2">
+            <a:schemeClr val="accent1"/>
+          </a:effectRef>
+          <a:fontRef idx="minor">
+            <a:schemeClr val="lt1"/>
+          </a:fontRef>
+        </p:style>
+        <p:txBody>
+          <a:bodyPr rtlCol="0" anchor="ctr"/>
+          <a:lstStyle/>
+          <a:p/>
+        </p:txBody>
+      </p:sp>
+      <p:sp>
+        <p:nvSpPr>
+          <p:cNvPr id="11" name="TextBox 10"/>
           <p:cNvSpPr txBox="1"/>
           <p:nvPr/>
         </p:nvSpPr>
         <p:spPr>
           <a:xfrm>
-            <a:off x="9144000" y="2496312"/>
-            <a:ext cx="2377440" cy="457200"/>
+            <a:off x="2926079" y="1755648"/>
+            <a:ext cx="1737360" cy="320040"/>
           </a:xfrm>
           <a:prstGeom prst="rect">
             <a:avLst/>
@@ -7440,43 +7431,27 @@
               </a:spcAft>
             </a:pPr>
             <a:r>
-              <a:rPr sz="1200" b="1" i="0">
+              <a:rPr sz="1400" b="1" i="0">
                 <a:solidFill>
                   <a:srgbClr val="F3F6FC"/>
                 </a:solidFill>
                 <a:latin typeface="Calibri"/>
               </a:rPr>
-              <a:t>scikit-learn</a:t>
-            </a:r>
-          </a:p>
-          <a:p>
-            <a:pPr algn="l">
-              <a:spcAft>
-                <a:spcPts val="400"/>
-              </a:spcAft>
-            </a:pPr>
-            <a:r>
-              <a:rPr sz="1050" b="0" i="0">
-                <a:solidFill>
-                  <a:srgbClr val="94A3B8"/>
-                </a:solidFill>
-                <a:latin typeface="Calibri"/>
-              </a:rPr>
-              <a:t>TF-IDF + logistic regression</a:t>
-            </a:r>
-          </a:p>
-        </p:txBody>
-      </p:sp>
-      <p:sp>
-        <p:nvSpPr>
-          <p:cNvPr id="11" name="TextBox 10"/>
+              <a:t>Ingestion</a:t>
+            </a:r>
+          </a:p>
+        </p:txBody>
+      </p:sp>
+      <p:sp>
+        <p:nvSpPr>
+          <p:cNvPr id="12" name="TextBox 11"/>
           <p:cNvSpPr txBox="1"/>
           <p:nvPr/>
         </p:nvSpPr>
         <p:spPr>
           <a:xfrm>
-            <a:off x="9144000" y="2980944"/>
-            <a:ext cx="2377440" cy="457200"/>
+            <a:off x="2926079" y="2103120"/>
+            <a:ext cx="1737360" cy="777240"/>
           </a:xfrm>
           <a:prstGeom prst="rect">
             <a:avLst/>
@@ -7495,43 +7470,74 @@
               </a:spcAft>
             </a:pPr>
             <a:r>
-              <a:rPr sz="1200" b="1" i="0">
-                <a:solidFill>
-                  <a:srgbClr val="F3F6FC"/>
-                </a:solidFill>
-                <a:latin typeface="Calibri"/>
-              </a:rPr>
-              <a:t>VADER</a:t>
-            </a:r>
-          </a:p>
-          <a:p>
-            <a:pPr algn="l">
-              <a:spcAft>
-                <a:spcPts val="400"/>
-              </a:spcAft>
-            </a:pPr>
-            <a:r>
-              <a:rPr sz="1050" b="0" i="0">
+              <a:rPr sz="1100" b="0" i="0">
                 <a:solidFill>
                   <a:srgbClr val="94A3B8"/>
                 </a:solidFill>
                 <a:latin typeface="Calibri"/>
               </a:rPr>
-              <a:t>+ finance lexicon</a:t>
-            </a:r>
-          </a:p>
-        </p:txBody>
-      </p:sp>
-      <p:sp>
-        <p:nvSpPr>
-          <p:cNvPr id="12" name="TextBox 11"/>
+              <a:t>validate · normalise UTC
+de-duplicate · stable IDs</a:t>
+            </a:r>
+          </a:p>
+        </p:txBody>
+      </p:sp>
+      <p:sp>
+        <p:nvSpPr>
+          <p:cNvPr id="13" name="Rounded Rectangle 12"/>
+          <p:cNvSpPr/>
+          <p:nvPr/>
+        </p:nvSpPr>
+        <p:spPr>
+          <a:xfrm>
+            <a:off x="5029200" y="1627632"/>
+            <a:ext cx="2011680" cy="1325880"/>
+          </a:xfrm>
+          <a:prstGeom prst="roundRect">
+            <a:avLst>
+              <a:gd name="adj" fmla="val 6000"/>
+            </a:avLst>
+          </a:prstGeom>
+          <a:solidFill>
+            <a:srgbClr val="18263B"/>
+          </a:solidFill>
+          <a:ln w="12700">
+            <a:solidFill>
+              <a:srgbClr val="4F7CFF"/>
+            </a:solidFill>
+          </a:ln>
+          <a:effectLst/>
+        </p:spPr>
+        <p:style>
+          <a:lnRef idx="1">
+            <a:schemeClr val="accent1"/>
+          </a:lnRef>
+          <a:fillRef idx="3">
+            <a:schemeClr val="accent1"/>
+          </a:fillRef>
+          <a:effectRef idx="2">
+            <a:schemeClr val="accent1"/>
+          </a:effectRef>
+          <a:fontRef idx="minor">
+            <a:schemeClr val="lt1"/>
+          </a:fontRef>
+        </p:style>
+        <p:txBody>
+          <a:bodyPr rtlCol="0" anchor="ctr"/>
+          <a:lstStyle/>
+          <a:p/>
+        </p:txBody>
+      </p:sp>
+      <p:sp>
+        <p:nvSpPr>
+          <p:cNvPr id="14" name="TextBox 13"/>
           <p:cNvSpPr txBox="1"/>
           <p:nvPr/>
         </p:nvSpPr>
         <p:spPr>
           <a:xfrm>
-            <a:off x="9144000" y="3465576"/>
-            <a:ext cx="2377440" cy="457200"/>
+            <a:off x="5166360" y="1755648"/>
+            <a:ext cx="1737360" cy="320040"/>
           </a:xfrm>
           <a:prstGeom prst="rect">
             <a:avLst/>
@@ -7550,43 +7556,27 @@
               </a:spcAft>
             </a:pPr>
             <a:r>
-              <a:rPr sz="1200" b="1" i="0">
+              <a:rPr sz="1400" b="1" i="0">
                 <a:solidFill>
                   <a:srgbClr val="F3F6FC"/>
                 </a:solidFill>
                 <a:latin typeface="Calibri"/>
               </a:rPr>
-              <a:t>Pydantic</a:t>
-            </a:r>
-          </a:p>
-          <a:p>
-            <a:pPr algn="l">
-              <a:spcAft>
-                <a:spcPts val="400"/>
-              </a:spcAft>
-            </a:pPr>
-            <a:r>
-              <a:rPr sz="1050" b="0" i="0">
-                <a:solidFill>
-                  <a:srgbClr val="94A3B8"/>
-                </a:solidFill>
-                <a:latin typeface="Calibri"/>
-              </a:rPr>
-              <a:t>validated signal schema</a:t>
-            </a:r>
-          </a:p>
-        </p:txBody>
-      </p:sp>
-      <p:sp>
-        <p:nvSpPr>
-          <p:cNvPr id="13" name="TextBox 12"/>
+              <a:t>NLP engine</a:t>
+            </a:r>
+          </a:p>
+        </p:txBody>
+      </p:sp>
+      <p:sp>
+        <p:nvSpPr>
+          <p:cNvPr id="15" name="TextBox 14"/>
           <p:cNvSpPr txBox="1"/>
           <p:nvPr/>
         </p:nvSpPr>
         <p:spPr>
           <a:xfrm>
-            <a:off x="9144000" y="3950208"/>
-            <a:ext cx="2377440" cy="457200"/>
+            <a:off x="5166360" y="2103120"/>
+            <a:ext cx="1737360" cy="777240"/>
           </a:xfrm>
           <a:prstGeom prst="rect">
             <a:avLst/>
@@ -7605,43 +7595,74 @@
               </a:spcAft>
             </a:pPr>
             <a:r>
-              <a:rPr sz="1200" b="1" i="0">
-                <a:solidFill>
-                  <a:srgbClr val="F3F6FC"/>
-                </a:solidFill>
-                <a:latin typeface="Calibri"/>
-              </a:rPr>
-              <a:t>FastAPI</a:t>
-            </a:r>
-          </a:p>
-          <a:p>
-            <a:pPr algn="l">
-              <a:spcAft>
-                <a:spcPts val="400"/>
-              </a:spcAft>
-            </a:pPr>
-            <a:r>
-              <a:rPr sz="1050" b="0" i="0">
+              <a:rPr sz="1100" b="0" i="0">
                 <a:solidFill>
                   <a:srgbClr val="94A3B8"/>
                 </a:solidFill>
                 <a:latin typeface="Calibri"/>
               </a:rPr>
-              <a:t>REST for downstream apps</a:t>
-            </a:r>
-          </a:p>
-        </p:txBody>
-      </p:sp>
-      <p:sp>
-        <p:nvSpPr>
-          <p:cNvPr id="14" name="TextBox 13"/>
+              <a:t>entities · sentiment
+event type · impact 1-10</a:t>
+            </a:r>
+          </a:p>
+        </p:txBody>
+      </p:sp>
+      <p:sp>
+        <p:nvSpPr>
+          <p:cNvPr id="16" name="Rounded Rectangle 15"/>
+          <p:cNvSpPr/>
+          <p:nvPr/>
+        </p:nvSpPr>
+        <p:spPr>
+          <a:xfrm>
+            <a:off x="7269480" y="1627632"/>
+            <a:ext cx="2011680" cy="1325880"/>
+          </a:xfrm>
+          <a:prstGeom prst="roundRect">
+            <a:avLst>
+              <a:gd name="adj" fmla="val 6000"/>
+            </a:avLst>
+          </a:prstGeom>
+          <a:solidFill>
+            <a:srgbClr val="18263B"/>
+          </a:solidFill>
+          <a:ln w="12700">
+            <a:solidFill>
+              <a:srgbClr val="F4B942"/>
+            </a:solidFill>
+          </a:ln>
+          <a:effectLst/>
+        </p:spPr>
+        <p:style>
+          <a:lnRef idx="1">
+            <a:schemeClr val="accent1"/>
+          </a:lnRef>
+          <a:fillRef idx="3">
+            <a:schemeClr val="accent1"/>
+          </a:fillRef>
+          <a:effectRef idx="2">
+            <a:schemeClr val="accent1"/>
+          </a:effectRef>
+          <a:fontRef idx="minor">
+            <a:schemeClr val="lt1"/>
+          </a:fontRef>
+        </p:style>
+        <p:txBody>
+          <a:bodyPr rtlCol="0" anchor="ctr"/>
+          <a:lstStyle/>
+          <a:p/>
+        </p:txBody>
+      </p:sp>
+      <p:sp>
+        <p:nvSpPr>
+          <p:cNvPr id="17" name="TextBox 16"/>
           <p:cNvSpPr txBox="1"/>
           <p:nvPr/>
         </p:nvSpPr>
         <p:spPr>
           <a:xfrm>
-            <a:off x="9144000" y="4434840"/>
-            <a:ext cx="2377440" cy="457200"/>
+            <a:off x="7406640" y="1755648"/>
+            <a:ext cx="1737360" cy="320040"/>
           </a:xfrm>
           <a:prstGeom prst="rect">
             <a:avLst/>
@@ -7660,43 +7681,27 @@
               </a:spcAft>
             </a:pPr>
             <a:r>
-              <a:rPr sz="1200" b="1" i="0">
-                <a:solidFill>
-                  <a:srgbClr val="F3F6FC"/>
-                </a:solidFill>
-                <a:latin typeface="Calibri"/>
-              </a:rPr>
-              <a:t>Streamlit + Plotly</a:t>
-            </a:r>
-          </a:p>
-          <a:p>
-            <a:pPr algn="l">
-              <a:spcAft>
-                <a:spcPts val="400"/>
-              </a:spcAft>
-            </a:pPr>
-            <a:r>
-              <a:rPr sz="1050" b="0" i="0">
-                <a:solidFill>
-                  <a:srgbClr val="94A3B8"/>
-                </a:solidFill>
-                <a:latin typeface="Calibri"/>
-              </a:rPr>
-              <a:t>6-page dashboard</a:t>
-            </a:r>
-          </a:p>
-        </p:txBody>
-      </p:sp>
-      <p:sp>
-        <p:nvSpPr>
-          <p:cNvPr id="15" name="TextBox 14"/>
+              <a:rPr sz="1400" b="1" i="0">
+                <a:solidFill>
+                  <a:srgbClr val="F4B942"/>
+                </a:solidFill>
+                <a:latin typeface="Calibri"/>
+              </a:rPr>
+              <a:t>Risk signal</a:t>
+            </a:r>
+          </a:p>
+        </p:txBody>
+      </p:sp>
+      <p:sp>
+        <p:nvSpPr>
+          <p:cNvPr id="18" name="TextBox 17"/>
           <p:cNvSpPr txBox="1"/>
           <p:nvPr/>
         </p:nvSpPr>
         <p:spPr>
           <a:xfrm>
-            <a:off x="9144000" y="4919472"/>
-            <a:ext cx="2377440" cy="457200"/>
+            <a:off x="7406640" y="2103120"/>
+            <a:ext cx="1737360" cy="777240"/>
           </a:xfrm>
           <a:prstGeom prst="rect">
             <a:avLst/>
@@ -7715,43 +7720,74 @@
               </a:spcAft>
             </a:pPr>
             <a:r>
-              <a:rPr sz="1200" b="1" i="0">
-                <a:solidFill>
-                  <a:srgbClr val="F3F6FC"/>
-                </a:solidFill>
-                <a:latin typeface="Calibri"/>
-              </a:rPr>
-              <a:t>PyYAML</a:t>
-            </a:r>
-          </a:p>
-          <a:p>
-            <a:pPr algn="l">
-              <a:spcAft>
-                <a:spcPts val="400"/>
-              </a:spcAft>
-            </a:pPr>
-            <a:r>
-              <a:rPr sz="1050" b="0" i="0">
+              <a:rPr sz="1100" b="0" i="0">
                 <a:solidFill>
                   <a:srgbClr val="94A3B8"/>
                 </a:solidFill>
                 <a:latin typeface="Calibri"/>
               </a:rPr>
-              <a:t>editable scenarios &amp; weights</a:t>
-            </a:r>
-          </a:p>
-        </p:txBody>
-      </p:sp>
-      <p:sp>
-        <p:nvSpPr>
-          <p:cNvPr id="16" name="TextBox 15"/>
+              <a:t>validated schema
++ plain-English reason</a:t>
+            </a:r>
+          </a:p>
+        </p:txBody>
+      </p:sp>
+      <p:sp>
+        <p:nvSpPr>
+          <p:cNvPr id="19" name="Rounded Rectangle 18"/>
+          <p:cNvSpPr/>
+          <p:nvPr/>
+        </p:nvSpPr>
+        <p:spPr>
+          <a:xfrm>
+            <a:off x="9509760" y="1627632"/>
+            <a:ext cx="2011680" cy="1325880"/>
+          </a:xfrm>
+          <a:prstGeom prst="roundRect">
+            <a:avLst>
+              <a:gd name="adj" fmla="val 6000"/>
+            </a:avLst>
+          </a:prstGeom>
+          <a:solidFill>
+            <a:srgbClr val="18263B"/>
+          </a:solidFill>
+          <a:ln w="12700">
+            <a:solidFill>
+              <a:srgbClr val="18A999"/>
+            </a:solidFill>
+          </a:ln>
+          <a:effectLst/>
+        </p:spPr>
+        <p:style>
+          <a:lnRef idx="1">
+            <a:schemeClr val="accent1"/>
+          </a:lnRef>
+          <a:fillRef idx="3">
+            <a:schemeClr val="accent1"/>
+          </a:fillRef>
+          <a:effectRef idx="2">
+            <a:schemeClr val="accent1"/>
+          </a:effectRef>
+          <a:fontRef idx="minor">
+            <a:schemeClr val="lt1"/>
+          </a:fontRef>
+        </p:style>
+        <p:txBody>
+          <a:bodyPr rtlCol="0" anchor="ctr"/>
+          <a:lstStyle/>
+          <a:p/>
+        </p:txBody>
+      </p:sp>
+      <p:sp>
+        <p:nvSpPr>
+          <p:cNvPr id="20" name="TextBox 19"/>
           <p:cNvSpPr txBox="1"/>
           <p:nvPr/>
         </p:nvSpPr>
         <p:spPr>
           <a:xfrm>
-            <a:off x="9144000" y="5404104"/>
-            <a:ext cx="2377440" cy="457200"/>
+            <a:off x="9646920" y="1755648"/>
+            <a:ext cx="1737360" cy="320040"/>
           </a:xfrm>
           <a:prstGeom prst="rect">
             <a:avLst/>
@@ -7770,43 +7806,27 @@
               </a:spcAft>
             </a:pPr>
             <a:r>
-              <a:rPr sz="1200" b="1" i="0">
+              <a:rPr sz="1400" b="1" i="0">
                 <a:solidFill>
                   <a:srgbClr val="F3F6FC"/>
                 </a:solidFill>
                 <a:latin typeface="Calibri"/>
               </a:rPr>
-              <a:t>Optional</a:t>
-            </a:r>
-          </a:p>
-          <a:p>
-            <a:pPr algn="l">
-              <a:spcAft>
-                <a:spcPts val="400"/>
-              </a:spcAft>
-            </a:pPr>
-            <a:r>
-              <a:rPr sz="1050" b="0" i="0">
-                <a:solidFill>
-                  <a:srgbClr val="94A3B8"/>
-                </a:solidFill>
-                <a:latin typeface="Calibri"/>
-              </a:rPr>
-              <a:t>FinBERT, BART-MNLI</a:t>
-            </a:r>
-          </a:p>
-        </p:txBody>
-      </p:sp>
-      <p:sp>
-        <p:nvSpPr>
-          <p:cNvPr id="17" name="TextBox 16"/>
+              <a:t>Consumers</a:t>
+            </a:r>
+          </a:p>
+        </p:txBody>
+      </p:sp>
+      <p:sp>
+        <p:nvSpPr>
+          <p:cNvPr id="21" name="TextBox 20"/>
           <p:cNvSpPr txBox="1"/>
           <p:nvPr/>
         </p:nvSpPr>
         <p:spPr>
           <a:xfrm>
-            <a:off x="548640" y="6053328"/>
-            <a:ext cx="8229600" cy="274320"/>
+            <a:off x="9646920" y="2103120"/>
+            <a:ext cx="1737360" cy="777240"/>
           </a:xfrm>
           <a:prstGeom prst="rect">
             <a:avLst/>
@@ -7825,13 +7845,1608 @@
               </a:spcAft>
             </a:pPr>
             <a:r>
-              <a:rPr sz="1150" b="0" i="0">
+              <a:rPr sz="1100" b="0" i="0">
                 <a:solidFill>
                   <a:srgbClr val="94A3B8"/>
                 </a:solidFill>
                 <a:latin typeface="Calibri"/>
               </a:rPr>
-              <a:t>Dashboard, API, CLI and reports call the same riskpulse modules: displayed and exported numbers always agree.</a:t>
+              <a:t>6-page dashboard
+REST API · JSON / CSV / HTML</a:t>
+            </a:r>
+          </a:p>
+        </p:txBody>
+      </p:sp>
+      <p:cxnSp>
+        <p:nvCxnSpPr>
+          <p:cNvPr id="22" name="Connector 21"/>
+          <p:cNvCxnSpPr/>
+          <p:nvPr/>
+        </p:nvCxnSpPr>
+        <p:spPr>
+          <a:xfrm>
+            <a:off x="2578608" y="2290572"/>
+            <a:ext cx="192024" cy="0"/>
+          </a:xfrm>
+          <a:prstGeom prst="line">
+            <a:avLst/>
+          </a:prstGeom>
+          <a:ln w="22225">
+            <a:solidFill>
+              <a:srgbClr val="4F7CFF"/>
+            </a:solidFill>
+            <a:tailEnd type="triangle"/>
+          </a:ln>
+        </p:spPr>
+        <p:style>
+          <a:lnRef idx="2">
+            <a:schemeClr val="accent1"/>
+          </a:lnRef>
+          <a:fillRef idx="0">
+            <a:schemeClr val="accent1"/>
+          </a:fillRef>
+          <a:effectRef idx="1">
+            <a:schemeClr val="accent1"/>
+          </a:effectRef>
+          <a:fontRef idx="minor">
+            <a:schemeClr val="tx1"/>
+          </a:fontRef>
+        </p:style>
+      </p:cxnSp>
+      <p:cxnSp>
+        <p:nvCxnSpPr>
+          <p:cNvPr id="23" name="Connector 22"/>
+          <p:cNvCxnSpPr/>
+          <p:nvPr/>
+        </p:nvCxnSpPr>
+        <p:spPr>
+          <a:xfrm>
+            <a:off x="4818888" y="2290572"/>
+            <a:ext cx="192024" cy="0"/>
+          </a:xfrm>
+          <a:prstGeom prst="line">
+            <a:avLst/>
+          </a:prstGeom>
+          <a:ln w="22225">
+            <a:solidFill>
+              <a:srgbClr val="4F7CFF"/>
+            </a:solidFill>
+            <a:tailEnd type="triangle"/>
+          </a:ln>
+        </p:spPr>
+        <p:style>
+          <a:lnRef idx="2">
+            <a:schemeClr val="accent1"/>
+          </a:lnRef>
+          <a:fillRef idx="0">
+            <a:schemeClr val="accent1"/>
+          </a:fillRef>
+          <a:effectRef idx="1">
+            <a:schemeClr val="accent1"/>
+          </a:effectRef>
+          <a:fontRef idx="minor">
+            <a:schemeClr val="tx1"/>
+          </a:fontRef>
+        </p:style>
+      </p:cxnSp>
+      <p:cxnSp>
+        <p:nvCxnSpPr>
+          <p:cNvPr id="24" name="Connector 23"/>
+          <p:cNvCxnSpPr/>
+          <p:nvPr/>
+        </p:nvCxnSpPr>
+        <p:spPr>
+          <a:xfrm>
+            <a:off x="7059168" y="2290572"/>
+            <a:ext cx="192024" cy="0"/>
+          </a:xfrm>
+          <a:prstGeom prst="line">
+            <a:avLst/>
+          </a:prstGeom>
+          <a:ln w="22225">
+            <a:solidFill>
+              <a:srgbClr val="4F7CFF"/>
+            </a:solidFill>
+            <a:tailEnd type="triangle"/>
+          </a:ln>
+        </p:spPr>
+        <p:style>
+          <a:lnRef idx="2">
+            <a:schemeClr val="accent1"/>
+          </a:lnRef>
+          <a:fillRef idx="0">
+            <a:schemeClr val="accent1"/>
+          </a:fillRef>
+          <a:effectRef idx="1">
+            <a:schemeClr val="accent1"/>
+          </a:effectRef>
+          <a:fontRef idx="minor">
+            <a:schemeClr val="tx1"/>
+          </a:fontRef>
+        </p:style>
+      </p:cxnSp>
+      <p:cxnSp>
+        <p:nvCxnSpPr>
+          <p:cNvPr id="25" name="Connector 24"/>
+          <p:cNvCxnSpPr/>
+          <p:nvPr/>
+        </p:nvCxnSpPr>
+        <p:spPr>
+          <a:xfrm>
+            <a:off x="9299448" y="2290572"/>
+            <a:ext cx="192024" cy="0"/>
+          </a:xfrm>
+          <a:prstGeom prst="line">
+            <a:avLst/>
+          </a:prstGeom>
+          <a:ln w="22225">
+            <a:solidFill>
+              <a:srgbClr val="4F7CFF"/>
+            </a:solidFill>
+            <a:tailEnd type="triangle"/>
+          </a:ln>
+        </p:spPr>
+        <p:style>
+          <a:lnRef idx="2">
+            <a:schemeClr val="accent1"/>
+          </a:lnRef>
+          <a:fillRef idx="0">
+            <a:schemeClr val="accent1"/>
+          </a:fillRef>
+          <a:effectRef idx="1">
+            <a:schemeClr val="accent1"/>
+          </a:effectRef>
+          <a:fontRef idx="minor">
+            <a:schemeClr val="tx1"/>
+          </a:fontRef>
+        </p:style>
+      </p:cxnSp>
+      <p:sp>
+        <p:nvSpPr>
+          <p:cNvPr id="26" name="TextBox 25"/>
+          <p:cNvSpPr txBox="1"/>
+          <p:nvPr/>
+        </p:nvSpPr>
+        <p:spPr>
+          <a:xfrm>
+            <a:off x="548640" y="3465576"/>
+            <a:ext cx="6400800" cy="274320"/>
+          </a:xfrm>
+          <a:prstGeom prst="rect">
+            <a:avLst/>
+          </a:prstGeom>
+          <a:noFill/>
+        </p:spPr>
+        <p:txBody>
+          <a:bodyPr wrap="square" lIns="0" rIns="0" tIns="0" bIns="0" anchor="t">
+            <a:spAutoFit/>
+          </a:bodyPr>
+          <a:lstStyle/>
+          <a:p>
+            <a:pPr algn="l">
+              <a:spcAft>
+                <a:spcPts val="400"/>
+              </a:spcAft>
+            </a:pPr>
+            <a:r>
+              <a:rPr sz="1050" b="1" i="0">
+                <a:solidFill>
+                  <a:srgbClr val="18A999"/>
+                </a:solidFill>
+                <a:latin typeface="Calibri"/>
+              </a:rPr>
+              <a:t>STRESS PATH  ·  Module B portfolio stress testing</a:t>
+            </a:r>
+          </a:p>
+        </p:txBody>
+      </p:sp>
+      <p:sp>
+        <p:nvSpPr>
+          <p:cNvPr id="27" name="Rounded Rectangle 26"/>
+          <p:cNvSpPr/>
+          <p:nvPr/>
+        </p:nvSpPr>
+        <p:spPr>
+          <a:xfrm>
+            <a:off x="548640" y="3767328"/>
+            <a:ext cx="2011680" cy="1325880"/>
+          </a:xfrm>
+          <a:prstGeom prst="roundRect">
+            <a:avLst>
+              <a:gd name="adj" fmla="val 6000"/>
+            </a:avLst>
+          </a:prstGeom>
+          <a:solidFill>
+            <a:srgbClr val="18263B"/>
+          </a:solidFill>
+          <a:ln w="12700">
+            <a:solidFill>
+              <a:srgbClr val="18A999"/>
+            </a:solidFill>
+          </a:ln>
+          <a:effectLst/>
+        </p:spPr>
+        <p:style>
+          <a:lnRef idx="1">
+            <a:schemeClr val="accent1"/>
+          </a:lnRef>
+          <a:fillRef idx="3">
+            <a:schemeClr val="accent1"/>
+          </a:fillRef>
+          <a:effectRef idx="2">
+            <a:schemeClr val="accent1"/>
+          </a:effectRef>
+          <a:fontRef idx="minor">
+            <a:schemeClr val="lt1"/>
+          </a:fontRef>
+        </p:style>
+        <p:txBody>
+          <a:bodyPr rtlCol="0" anchor="ctr"/>
+          <a:lstStyle/>
+          <a:p/>
+        </p:txBody>
+      </p:sp>
+      <p:sp>
+        <p:nvSpPr>
+          <p:cNvPr id="28" name="TextBox 27"/>
+          <p:cNvSpPr txBox="1"/>
+          <p:nvPr/>
+        </p:nvSpPr>
+        <p:spPr>
+          <a:xfrm>
+            <a:off x="685800" y="3895344"/>
+            <a:ext cx="1737360" cy="320040"/>
+          </a:xfrm>
+          <a:prstGeom prst="rect">
+            <a:avLst/>
+          </a:prstGeom>
+          <a:noFill/>
+        </p:spPr>
+        <p:txBody>
+          <a:bodyPr wrap="square" lIns="0" rIns="0" tIns="0" bIns="0" anchor="t">
+            <a:spAutoFit/>
+          </a:bodyPr>
+          <a:lstStyle/>
+          <a:p>
+            <a:pPr algn="l">
+              <a:spcAft>
+                <a:spcPts val="400"/>
+              </a:spcAft>
+            </a:pPr>
+            <a:r>
+              <a:rPr sz="1400" b="1" i="0">
+                <a:solidFill>
+                  <a:srgbClr val="F3F6FC"/>
+                </a:solidFill>
+                <a:latin typeface="Calibri"/>
+              </a:rPr>
+              <a:t>Synthetic portfolio</a:t>
+            </a:r>
+          </a:p>
+        </p:txBody>
+      </p:sp>
+      <p:sp>
+        <p:nvSpPr>
+          <p:cNvPr id="29" name="TextBox 28"/>
+          <p:cNvSpPr txBox="1"/>
+          <p:nvPr/>
+        </p:nvSpPr>
+        <p:spPr>
+          <a:xfrm>
+            <a:off x="685800" y="4242816"/>
+            <a:ext cx="1737360" cy="777240"/>
+          </a:xfrm>
+          <a:prstGeom prst="rect">
+            <a:avLst/>
+          </a:prstGeom>
+          <a:noFill/>
+        </p:spPr>
+        <p:txBody>
+          <a:bodyPr wrap="square" lIns="0" rIns="0" tIns="0" bIns="0" anchor="t">
+            <a:spAutoFit/>
+          </a:bodyPr>
+          <a:lstStyle/>
+          <a:p>
+            <a:pPr algn="l">
+              <a:spcAft>
+                <a:spcPts val="400"/>
+              </a:spcAft>
+            </a:pPr>
+            <a:r>
+              <a:rPr sz="1100" b="0" i="0">
+                <a:solidFill>
+                  <a:srgbClr val="94A3B8"/>
+                </a:solidFill>
+                <a:latin typeface="Calibri"/>
+              </a:rPr>
+              <a:t>37 positions · ~$1.02bn
+loans, bonds, equity, FX, derivs</a:t>
+            </a:r>
+          </a:p>
+        </p:txBody>
+      </p:sp>
+      <p:sp>
+        <p:nvSpPr>
+          <p:cNvPr id="30" name="Rounded Rectangle 29"/>
+          <p:cNvSpPr/>
+          <p:nvPr/>
+        </p:nvSpPr>
+        <p:spPr>
+          <a:xfrm>
+            <a:off x="5029200" y="3767328"/>
+            <a:ext cx="2011680" cy="1325880"/>
+          </a:xfrm>
+          <a:prstGeom prst="roundRect">
+            <a:avLst>
+              <a:gd name="adj" fmla="val 6000"/>
+            </a:avLst>
+          </a:prstGeom>
+          <a:solidFill>
+            <a:srgbClr val="18263B"/>
+          </a:solidFill>
+          <a:ln w="12700">
+            <a:solidFill>
+              <a:srgbClr val="18A999"/>
+            </a:solidFill>
+          </a:ln>
+          <a:effectLst/>
+        </p:spPr>
+        <p:style>
+          <a:lnRef idx="1">
+            <a:schemeClr val="accent1"/>
+          </a:lnRef>
+          <a:fillRef idx="3">
+            <a:schemeClr val="accent1"/>
+          </a:fillRef>
+          <a:effectRef idx="2">
+            <a:schemeClr val="accent1"/>
+          </a:effectRef>
+          <a:fontRef idx="minor">
+            <a:schemeClr val="lt1"/>
+          </a:fontRef>
+        </p:style>
+        <p:txBody>
+          <a:bodyPr rtlCol="0" anchor="ctr"/>
+          <a:lstStyle/>
+          <a:p/>
+        </p:txBody>
+      </p:sp>
+      <p:sp>
+        <p:nvSpPr>
+          <p:cNvPr id="31" name="TextBox 30"/>
+          <p:cNvSpPr txBox="1"/>
+          <p:nvPr/>
+        </p:nvSpPr>
+        <p:spPr>
+          <a:xfrm>
+            <a:off x="5166360" y="3895344"/>
+            <a:ext cx="1737360" cy="320040"/>
+          </a:xfrm>
+          <a:prstGeom prst="rect">
+            <a:avLst/>
+          </a:prstGeom>
+          <a:noFill/>
+        </p:spPr>
+        <p:txBody>
+          <a:bodyPr wrap="square" lIns="0" rIns="0" tIns="0" bIns="0" anchor="t">
+            <a:spAutoFit/>
+          </a:bodyPr>
+          <a:lstStyle/>
+          <a:p>
+            <a:pPr algn="l">
+              <a:spcAft>
+                <a:spcPts val="400"/>
+              </a:spcAft>
+            </a:pPr>
+            <a:r>
+              <a:rPr sz="1400" b="1" i="0">
+                <a:solidFill>
+                  <a:srgbClr val="F3F6FC"/>
+                </a:solidFill>
+                <a:latin typeface="Calibri"/>
+              </a:rPr>
+              <a:t>Trigger</a:t>
+            </a:r>
+          </a:p>
+        </p:txBody>
+      </p:sp>
+      <p:sp>
+        <p:nvSpPr>
+          <p:cNvPr id="32" name="TextBox 31"/>
+          <p:cNvSpPr txBox="1"/>
+          <p:nvPr/>
+        </p:nvSpPr>
+        <p:spPr>
+          <a:xfrm>
+            <a:off x="5166360" y="4242816"/>
+            <a:ext cx="1737360" cy="777240"/>
+          </a:xfrm>
+          <a:prstGeom prst="rect">
+            <a:avLst/>
+          </a:prstGeom>
+          <a:noFill/>
+        </p:spPr>
+        <p:txBody>
+          <a:bodyPr wrap="square" lIns="0" rIns="0" tIns="0" bIns="0" anchor="t">
+            <a:spAutoFit/>
+          </a:bodyPr>
+          <a:lstStyle/>
+          <a:p>
+            <a:pPr algn="l">
+              <a:spcAft>
+                <a:spcPts val="400"/>
+              </a:spcAft>
+            </a:pPr>
+            <a:r>
+              <a:rPr sz="1100" b="0" i="0">
+                <a:solidFill>
+                  <a:srgbClr val="94A3B8"/>
+                </a:solidFill>
+                <a:latin typeface="Calibri"/>
+              </a:rPr>
+              <a:t>impact &gt; 7 (configurable)
+event type -&gt; scenario</a:t>
+            </a:r>
+          </a:p>
+        </p:txBody>
+      </p:sp>
+      <p:sp>
+        <p:nvSpPr>
+          <p:cNvPr id="33" name="Rounded Rectangle 32"/>
+          <p:cNvSpPr/>
+          <p:nvPr/>
+        </p:nvSpPr>
+        <p:spPr>
+          <a:xfrm>
+            <a:off x="7269480" y="3767328"/>
+            <a:ext cx="2011680" cy="1325880"/>
+          </a:xfrm>
+          <a:prstGeom prst="roundRect">
+            <a:avLst>
+              <a:gd name="adj" fmla="val 6000"/>
+            </a:avLst>
+          </a:prstGeom>
+          <a:solidFill>
+            <a:srgbClr val="18263B"/>
+          </a:solidFill>
+          <a:ln w="12700">
+            <a:solidFill>
+              <a:srgbClr val="18A999"/>
+            </a:solidFill>
+          </a:ln>
+          <a:effectLst/>
+        </p:spPr>
+        <p:style>
+          <a:lnRef idx="1">
+            <a:schemeClr val="accent1"/>
+          </a:lnRef>
+          <a:fillRef idx="3">
+            <a:schemeClr val="accent1"/>
+          </a:fillRef>
+          <a:effectRef idx="2">
+            <a:schemeClr val="accent1"/>
+          </a:effectRef>
+          <a:fontRef idx="minor">
+            <a:schemeClr val="lt1"/>
+          </a:fontRef>
+        </p:style>
+        <p:txBody>
+          <a:bodyPr rtlCol="0" anchor="ctr"/>
+          <a:lstStyle/>
+          <a:p/>
+        </p:txBody>
+      </p:sp>
+      <p:sp>
+        <p:nvSpPr>
+          <p:cNvPr id="34" name="TextBox 33"/>
+          <p:cNvSpPr txBox="1"/>
+          <p:nvPr/>
+        </p:nvSpPr>
+        <p:spPr>
+          <a:xfrm>
+            <a:off x="7406640" y="3895344"/>
+            <a:ext cx="1737360" cy="320040"/>
+          </a:xfrm>
+          <a:prstGeom prst="rect">
+            <a:avLst/>
+          </a:prstGeom>
+          <a:noFill/>
+        </p:spPr>
+        <p:txBody>
+          <a:bodyPr wrap="square" lIns="0" rIns="0" tIns="0" bIns="0" anchor="t">
+            <a:spAutoFit/>
+          </a:bodyPr>
+          <a:lstStyle/>
+          <a:p>
+            <a:pPr algn="l">
+              <a:spcAft>
+                <a:spcPts val="400"/>
+              </a:spcAft>
+            </a:pPr>
+            <a:r>
+              <a:rPr sz="1400" b="1" i="0">
+                <a:solidFill>
+                  <a:srgbClr val="F3F6FC"/>
+                </a:solidFill>
+                <a:latin typeface="Calibri"/>
+              </a:rPr>
+              <a:t>Scenario library</a:t>
+            </a:r>
+          </a:p>
+        </p:txBody>
+      </p:sp>
+      <p:sp>
+        <p:nvSpPr>
+          <p:cNvPr id="35" name="TextBox 34"/>
+          <p:cNvSpPr txBox="1"/>
+          <p:nvPr/>
+        </p:nvSpPr>
+        <p:spPr>
+          <a:xfrm>
+            <a:off x="7406640" y="4242816"/>
+            <a:ext cx="1737360" cy="777240"/>
+          </a:xfrm>
+          <a:prstGeom prst="rect">
+            <a:avLst/>
+          </a:prstGeom>
+          <a:noFill/>
+        </p:spPr>
+        <p:txBody>
+          <a:bodyPr wrap="square" lIns="0" rIns="0" tIns="0" bIns="0" anchor="t">
+            <a:spAutoFit/>
+          </a:bodyPr>
+          <a:lstStyle/>
+          <a:p>
+            <a:pPr algn="l">
+              <a:spcAft>
+                <a:spcPts val="400"/>
+              </a:spcAft>
+            </a:pPr>
+            <a:r>
+              <a:rPr sz="1100" b="0" i="0">
+                <a:solidFill>
+                  <a:srgbClr val="94A3B8"/>
+                </a:solidFill>
+                <a:latin typeface="Calibri"/>
+              </a:rPr>
+              <a:t>10 scenarios in YAML
+rates, spreads, FX, PD, oil</a:t>
+            </a:r>
+          </a:p>
+        </p:txBody>
+      </p:sp>
+      <p:sp>
+        <p:nvSpPr>
+          <p:cNvPr id="36" name="Rounded Rectangle 35"/>
+          <p:cNvSpPr/>
+          <p:nvPr/>
+        </p:nvSpPr>
+        <p:spPr>
+          <a:xfrm>
+            <a:off x="9509760" y="3767328"/>
+            <a:ext cx="2011680" cy="1325880"/>
+          </a:xfrm>
+          <a:prstGeom prst="roundRect">
+            <a:avLst>
+              <a:gd name="adj" fmla="val 6000"/>
+            </a:avLst>
+          </a:prstGeom>
+          <a:solidFill>
+            <a:srgbClr val="18263B"/>
+          </a:solidFill>
+          <a:ln w="12700">
+            <a:solidFill>
+              <a:srgbClr val="18A999"/>
+            </a:solidFill>
+          </a:ln>
+          <a:effectLst/>
+        </p:spPr>
+        <p:style>
+          <a:lnRef idx="1">
+            <a:schemeClr val="accent1"/>
+          </a:lnRef>
+          <a:fillRef idx="3">
+            <a:schemeClr val="accent1"/>
+          </a:fillRef>
+          <a:effectRef idx="2">
+            <a:schemeClr val="accent1"/>
+          </a:effectRef>
+          <a:fontRef idx="minor">
+            <a:schemeClr val="lt1"/>
+          </a:fontRef>
+        </p:style>
+        <p:txBody>
+          <a:bodyPr rtlCol="0" anchor="ctr"/>
+          <a:lstStyle/>
+          <a:p/>
+        </p:txBody>
+      </p:sp>
+      <p:sp>
+        <p:nvSpPr>
+          <p:cNvPr id="37" name="TextBox 36"/>
+          <p:cNvSpPr txBox="1"/>
+          <p:nvPr/>
+        </p:nvSpPr>
+        <p:spPr>
+          <a:xfrm>
+            <a:off x="9646920" y="3895344"/>
+            <a:ext cx="1737360" cy="320040"/>
+          </a:xfrm>
+          <a:prstGeom prst="rect">
+            <a:avLst/>
+          </a:prstGeom>
+          <a:noFill/>
+        </p:spPr>
+        <p:txBody>
+          <a:bodyPr wrap="square" lIns="0" rIns="0" tIns="0" bIns="0" anchor="t">
+            <a:spAutoFit/>
+          </a:bodyPr>
+          <a:lstStyle/>
+          <a:p>
+            <a:pPr algn="l">
+              <a:spcAft>
+                <a:spcPts val="400"/>
+              </a:spcAft>
+            </a:pPr>
+            <a:r>
+              <a:rPr sz="1400" b="1" i="0">
+                <a:solidFill>
+                  <a:srgbClr val="F3F6FC"/>
+                </a:solidFill>
+                <a:latin typeface="Calibri"/>
+              </a:rPr>
+              <a:t>Factor P&amp;L engine</a:t>
+            </a:r>
+          </a:p>
+        </p:txBody>
+      </p:sp>
+      <p:sp>
+        <p:nvSpPr>
+          <p:cNvPr id="38" name="TextBox 37"/>
+          <p:cNvSpPr txBox="1"/>
+          <p:nvPr/>
+        </p:nvSpPr>
+        <p:spPr>
+          <a:xfrm>
+            <a:off x="9646920" y="4242816"/>
+            <a:ext cx="1737360" cy="777240"/>
+          </a:xfrm>
+          <a:prstGeom prst="rect">
+            <a:avLst/>
+          </a:prstGeom>
+          <a:noFill/>
+        </p:spPr>
+        <p:txBody>
+          <a:bodyPr wrap="square" lIns="0" rIns="0" tIns="0" bIns="0" anchor="t">
+            <a:spAutoFit/>
+          </a:bodyPr>
+          <a:lstStyle/>
+          <a:p>
+            <a:pPr algn="l">
+              <a:spcAft>
+                <a:spcPts val="400"/>
+              </a:spcAft>
+            </a:pPr>
+            <a:r>
+              <a:rPr sz="1100" b="0" i="0">
+                <a:solidFill>
+                  <a:srgbClr val="94A3B8"/>
+                </a:solidFill>
+                <a:latin typeface="Calibri"/>
+              </a:rPr>
+              <a:t>duration · beta · delta
+PD x LGD · liquidity haircut</a:t>
+            </a:r>
+          </a:p>
+        </p:txBody>
+      </p:sp>
+      <p:cxnSp>
+        <p:nvCxnSpPr>
+          <p:cNvPr id="39" name="Connector 38"/>
+          <p:cNvCxnSpPr/>
+          <p:nvPr/>
+        </p:nvCxnSpPr>
+        <p:spPr>
+          <a:xfrm>
+            <a:off x="8275320" y="2953512"/>
+            <a:ext cx="0" cy="356616"/>
+          </a:xfrm>
+          <a:prstGeom prst="line">
+            <a:avLst/>
+          </a:prstGeom>
+          <a:ln w="22225">
+            <a:solidFill>
+              <a:srgbClr val="18A999"/>
+            </a:solidFill>
+          </a:ln>
+        </p:spPr>
+        <p:style>
+          <a:lnRef idx="2">
+            <a:schemeClr val="accent1"/>
+          </a:lnRef>
+          <a:fillRef idx="0">
+            <a:schemeClr val="accent1"/>
+          </a:fillRef>
+          <a:effectRef idx="1">
+            <a:schemeClr val="accent1"/>
+          </a:effectRef>
+          <a:fontRef idx="minor">
+            <a:schemeClr val="tx1"/>
+          </a:fontRef>
+        </p:style>
+      </p:cxnSp>
+      <p:cxnSp>
+        <p:nvCxnSpPr>
+          <p:cNvPr id="40" name="Connector 39"/>
+          <p:cNvCxnSpPr/>
+          <p:nvPr/>
+        </p:nvCxnSpPr>
+        <p:spPr>
+          <a:xfrm flipH="1">
+            <a:off x="6035040" y="3310128"/>
+            <a:ext cx="2240280" cy="0"/>
+          </a:xfrm>
+          <a:prstGeom prst="line">
+            <a:avLst/>
+          </a:prstGeom>
+          <a:ln w="22225">
+            <a:solidFill>
+              <a:srgbClr val="18A999"/>
+            </a:solidFill>
+          </a:ln>
+        </p:spPr>
+        <p:style>
+          <a:lnRef idx="2">
+            <a:schemeClr val="accent1"/>
+          </a:lnRef>
+          <a:fillRef idx="0">
+            <a:schemeClr val="accent1"/>
+          </a:fillRef>
+          <a:effectRef idx="1">
+            <a:schemeClr val="accent1"/>
+          </a:effectRef>
+          <a:fontRef idx="minor">
+            <a:schemeClr val="tx1"/>
+          </a:fontRef>
+        </p:style>
+      </p:cxnSp>
+      <p:cxnSp>
+        <p:nvCxnSpPr>
+          <p:cNvPr id="41" name="Connector 40"/>
+          <p:cNvCxnSpPr/>
+          <p:nvPr/>
+        </p:nvCxnSpPr>
+        <p:spPr>
+          <a:xfrm>
+            <a:off x="6035040" y="3310128"/>
+            <a:ext cx="0" cy="438912"/>
+          </a:xfrm>
+          <a:prstGeom prst="line">
+            <a:avLst/>
+          </a:prstGeom>
+          <a:ln w="22225">
+            <a:solidFill>
+              <a:srgbClr val="18A999"/>
+            </a:solidFill>
+            <a:tailEnd type="triangle"/>
+          </a:ln>
+        </p:spPr>
+        <p:style>
+          <a:lnRef idx="2">
+            <a:schemeClr val="accent1"/>
+          </a:lnRef>
+          <a:fillRef idx="0">
+            <a:schemeClr val="accent1"/>
+          </a:fillRef>
+          <a:effectRef idx="1">
+            <a:schemeClr val="accent1"/>
+          </a:effectRef>
+          <a:fontRef idx="minor">
+            <a:schemeClr val="tx1"/>
+          </a:fontRef>
+        </p:style>
+      </p:cxnSp>
+      <p:sp>
+        <p:nvSpPr>
+          <p:cNvPr id="42" name="TextBox 41"/>
+          <p:cNvSpPr txBox="1"/>
+          <p:nvPr/>
+        </p:nvSpPr>
+        <p:spPr>
+          <a:xfrm>
+            <a:off x="6172200" y="3346704"/>
+            <a:ext cx="2011680" cy="228600"/>
+          </a:xfrm>
+          <a:prstGeom prst="rect">
+            <a:avLst/>
+          </a:prstGeom>
+          <a:noFill/>
+        </p:spPr>
+        <p:txBody>
+          <a:bodyPr wrap="square" lIns="0" rIns="0" tIns="0" bIns="0" anchor="t">
+            <a:spAutoFit/>
+          </a:bodyPr>
+          <a:lstStyle/>
+          <a:p>
+            <a:pPr algn="l">
+              <a:spcAft>
+                <a:spcPts val="400"/>
+              </a:spcAft>
+            </a:pPr>
+            <a:r>
+              <a:rPr sz="1000" b="0" i="1">
+                <a:solidFill>
+                  <a:srgbClr val="18A999"/>
+                </a:solidFill>
+                <a:latin typeface="Calibri"/>
+              </a:rPr>
+              <a:t>impact &gt; 7</a:t>
+            </a:r>
+          </a:p>
+        </p:txBody>
+      </p:sp>
+      <p:cxnSp>
+        <p:nvCxnSpPr>
+          <p:cNvPr id="43" name="Connector 42"/>
+          <p:cNvCxnSpPr/>
+          <p:nvPr/>
+        </p:nvCxnSpPr>
+        <p:spPr>
+          <a:xfrm>
+            <a:off x="7059168" y="4430268"/>
+            <a:ext cx="192024" cy="0"/>
+          </a:xfrm>
+          <a:prstGeom prst="line">
+            <a:avLst/>
+          </a:prstGeom>
+          <a:ln w="22225">
+            <a:solidFill>
+              <a:srgbClr val="18A999"/>
+            </a:solidFill>
+            <a:tailEnd type="triangle"/>
+          </a:ln>
+        </p:spPr>
+        <p:style>
+          <a:lnRef idx="2">
+            <a:schemeClr val="accent1"/>
+          </a:lnRef>
+          <a:fillRef idx="0">
+            <a:schemeClr val="accent1"/>
+          </a:fillRef>
+          <a:effectRef idx="1">
+            <a:schemeClr val="accent1"/>
+          </a:effectRef>
+          <a:fontRef idx="minor">
+            <a:schemeClr val="tx1"/>
+          </a:fontRef>
+        </p:style>
+      </p:cxnSp>
+      <p:cxnSp>
+        <p:nvCxnSpPr>
+          <p:cNvPr id="44" name="Connector 43"/>
+          <p:cNvCxnSpPr/>
+          <p:nvPr/>
+        </p:nvCxnSpPr>
+        <p:spPr>
+          <a:xfrm>
+            <a:off x="9299448" y="4430268"/>
+            <a:ext cx="192024" cy="0"/>
+          </a:xfrm>
+          <a:prstGeom prst="line">
+            <a:avLst/>
+          </a:prstGeom>
+          <a:ln w="22225">
+            <a:solidFill>
+              <a:srgbClr val="18A999"/>
+            </a:solidFill>
+            <a:tailEnd type="triangle"/>
+          </a:ln>
+        </p:spPr>
+        <p:style>
+          <a:lnRef idx="2">
+            <a:schemeClr val="accent1"/>
+          </a:lnRef>
+          <a:fillRef idx="0">
+            <a:schemeClr val="accent1"/>
+          </a:fillRef>
+          <a:effectRef idx="1">
+            <a:schemeClr val="accent1"/>
+          </a:effectRef>
+          <a:fontRef idx="minor">
+            <a:schemeClr val="tx1"/>
+          </a:fontRef>
+        </p:style>
+      </p:cxnSp>
+      <p:cxnSp>
+        <p:nvCxnSpPr>
+          <p:cNvPr id="45" name="Connector 44"/>
+          <p:cNvCxnSpPr/>
+          <p:nvPr/>
+        </p:nvCxnSpPr>
+        <p:spPr>
+          <a:xfrm flipV="1">
+            <a:off x="10515600" y="2971800"/>
+            <a:ext cx="0" cy="777240"/>
+          </a:xfrm>
+          <a:prstGeom prst="line">
+            <a:avLst/>
+          </a:prstGeom>
+          <a:ln w="22225">
+            <a:solidFill>
+              <a:srgbClr val="18A999"/>
+            </a:solidFill>
+            <a:tailEnd type="triangle"/>
+          </a:ln>
+        </p:spPr>
+        <p:style>
+          <a:lnRef idx="2">
+            <a:schemeClr val="accent1"/>
+          </a:lnRef>
+          <a:fillRef idx="0">
+            <a:schemeClr val="accent1"/>
+          </a:fillRef>
+          <a:effectRef idx="1">
+            <a:schemeClr val="accent1"/>
+          </a:effectRef>
+          <a:fontRef idx="minor">
+            <a:schemeClr val="tx1"/>
+          </a:fontRef>
+        </p:style>
+      </p:cxnSp>
+      <p:cxnSp>
+        <p:nvCxnSpPr>
+          <p:cNvPr id="46" name="Connector 45"/>
+          <p:cNvCxnSpPr/>
+          <p:nvPr/>
+        </p:nvCxnSpPr>
+        <p:spPr>
+          <a:xfrm>
+            <a:off x="1554480" y="5093208"/>
+            <a:ext cx="0" cy="274320"/>
+          </a:xfrm>
+          <a:prstGeom prst="line">
+            <a:avLst/>
+          </a:prstGeom>
+          <a:ln w="22225">
+            <a:solidFill>
+              <a:srgbClr val="18A999"/>
+            </a:solidFill>
+          </a:ln>
+        </p:spPr>
+        <p:style>
+          <a:lnRef idx="2">
+            <a:schemeClr val="accent1"/>
+          </a:lnRef>
+          <a:fillRef idx="0">
+            <a:schemeClr val="accent1"/>
+          </a:fillRef>
+          <a:effectRef idx="1">
+            <a:schemeClr val="accent1"/>
+          </a:effectRef>
+          <a:fontRef idx="minor">
+            <a:schemeClr val="tx1"/>
+          </a:fontRef>
+        </p:style>
+      </p:cxnSp>
+      <p:cxnSp>
+        <p:nvCxnSpPr>
+          <p:cNvPr id="47" name="Connector 46"/>
+          <p:cNvCxnSpPr/>
+          <p:nvPr/>
+        </p:nvCxnSpPr>
+        <p:spPr>
+          <a:xfrm>
+            <a:off x="1554480" y="5367528"/>
+            <a:ext cx="8961120" cy="0"/>
+          </a:xfrm>
+          <a:prstGeom prst="line">
+            <a:avLst/>
+          </a:prstGeom>
+          <a:ln w="22225">
+            <a:solidFill>
+              <a:srgbClr val="18A999"/>
+            </a:solidFill>
+          </a:ln>
+        </p:spPr>
+        <p:style>
+          <a:lnRef idx="2">
+            <a:schemeClr val="accent1"/>
+          </a:lnRef>
+          <a:fillRef idx="0">
+            <a:schemeClr val="accent1"/>
+          </a:fillRef>
+          <a:effectRef idx="1">
+            <a:schemeClr val="accent1"/>
+          </a:effectRef>
+          <a:fontRef idx="minor">
+            <a:schemeClr val="tx1"/>
+          </a:fontRef>
+        </p:style>
+      </p:cxnSp>
+      <p:cxnSp>
+        <p:nvCxnSpPr>
+          <p:cNvPr id="48" name="Connector 47"/>
+          <p:cNvCxnSpPr/>
+          <p:nvPr/>
+        </p:nvCxnSpPr>
+        <p:spPr>
+          <a:xfrm flipV="1">
+            <a:off x="10515600" y="5111496"/>
+            <a:ext cx="0" cy="256032"/>
+          </a:xfrm>
+          <a:prstGeom prst="line">
+            <a:avLst/>
+          </a:prstGeom>
+          <a:ln w="22225">
+            <a:solidFill>
+              <a:srgbClr val="18A999"/>
+            </a:solidFill>
+            <a:tailEnd type="triangle"/>
+          </a:ln>
+        </p:spPr>
+        <p:style>
+          <a:lnRef idx="2">
+            <a:schemeClr val="accent1"/>
+          </a:lnRef>
+          <a:fillRef idx="0">
+            <a:schemeClr val="accent1"/>
+          </a:fillRef>
+          <a:effectRef idx="1">
+            <a:schemeClr val="accent1"/>
+          </a:effectRef>
+          <a:fontRef idx="minor">
+            <a:schemeClr val="tx1"/>
+          </a:fontRef>
+        </p:style>
+      </p:cxnSp>
+      <p:sp>
+        <p:nvSpPr>
+          <p:cNvPr id="49" name="Rounded Rectangle 48"/>
+          <p:cNvSpPr/>
+          <p:nvPr/>
+        </p:nvSpPr>
+        <p:spPr>
+          <a:xfrm>
+            <a:off x="548640" y="5760720"/>
+            <a:ext cx="1161288" cy="292608"/>
+          </a:xfrm>
+          <a:prstGeom prst="roundRect">
+            <a:avLst>
+              <a:gd name="adj" fmla="val 50000"/>
+            </a:avLst>
+          </a:prstGeom>
+          <a:solidFill>
+            <a:srgbClr val="111B2E"/>
+          </a:solidFill>
+          <a:ln w="12700">
+            <a:solidFill>
+              <a:srgbClr val="94A3B8"/>
+            </a:solidFill>
+          </a:ln>
+          <a:effectLst/>
+        </p:spPr>
+        <p:style>
+          <a:lnRef idx="1">
+            <a:schemeClr val="accent1"/>
+          </a:lnRef>
+          <a:fillRef idx="3">
+            <a:schemeClr val="accent1"/>
+          </a:fillRef>
+          <a:effectRef idx="2">
+            <a:schemeClr val="accent1"/>
+          </a:effectRef>
+          <a:fontRef idx="minor">
+            <a:schemeClr val="lt1"/>
+          </a:fontRef>
+        </p:style>
+        <p:txBody>
+          <a:bodyPr rtlCol="0" anchor="ctr" lIns="45720" rIns="45720" tIns="0" bIns="0"/>
+          <a:lstStyle/>
+          <a:p>
+            <a:pPr algn="ctr"/>
+            <a:r>
+              <a:rPr sz="1050" b="1">
+                <a:solidFill>
+                  <a:srgbClr val="94A3B8"/>
+                </a:solidFill>
+                <a:latin typeface="Calibri"/>
+              </a:rPr>
+              <a:t>Python 3.11</a:t>
+            </a:r>
+          </a:p>
+        </p:txBody>
+      </p:sp>
+      <p:sp>
+        <p:nvSpPr>
+          <p:cNvPr id="50" name="Rounded Rectangle 49"/>
+          <p:cNvSpPr/>
+          <p:nvPr/>
+        </p:nvSpPr>
+        <p:spPr>
+          <a:xfrm>
+            <a:off x="1787652" y="5760720"/>
+            <a:ext cx="1161288" cy="292608"/>
+          </a:xfrm>
+          <a:prstGeom prst="roundRect">
+            <a:avLst>
+              <a:gd name="adj" fmla="val 50000"/>
+            </a:avLst>
+          </a:prstGeom>
+          <a:solidFill>
+            <a:srgbClr val="111B2E"/>
+          </a:solidFill>
+          <a:ln w="12700">
+            <a:solidFill>
+              <a:srgbClr val="94A3B8"/>
+            </a:solidFill>
+          </a:ln>
+          <a:effectLst/>
+        </p:spPr>
+        <p:style>
+          <a:lnRef idx="1">
+            <a:schemeClr val="accent1"/>
+          </a:lnRef>
+          <a:fillRef idx="3">
+            <a:schemeClr val="accent1"/>
+          </a:fillRef>
+          <a:effectRef idx="2">
+            <a:schemeClr val="accent1"/>
+          </a:effectRef>
+          <a:fontRef idx="minor">
+            <a:schemeClr val="lt1"/>
+          </a:fontRef>
+        </p:style>
+        <p:txBody>
+          <a:bodyPr rtlCol="0" anchor="ctr" lIns="45720" rIns="45720" tIns="0" bIns="0"/>
+          <a:lstStyle/>
+          <a:p>
+            <a:pPr algn="ctr"/>
+            <a:r>
+              <a:rPr sz="1050" b="1">
+                <a:solidFill>
+                  <a:srgbClr val="94A3B8"/>
+                </a:solidFill>
+                <a:latin typeface="Calibri"/>
+              </a:rPr>
+              <a:t>pandas</a:t>
+            </a:r>
+          </a:p>
+        </p:txBody>
+      </p:sp>
+      <p:sp>
+        <p:nvSpPr>
+          <p:cNvPr id="51" name="Rounded Rectangle 50"/>
+          <p:cNvSpPr/>
+          <p:nvPr/>
+        </p:nvSpPr>
+        <p:spPr>
+          <a:xfrm>
+            <a:off x="3026664" y="5760720"/>
+            <a:ext cx="1161288" cy="292608"/>
+          </a:xfrm>
+          <a:prstGeom prst="roundRect">
+            <a:avLst>
+              <a:gd name="adj" fmla="val 50000"/>
+            </a:avLst>
+          </a:prstGeom>
+          <a:solidFill>
+            <a:srgbClr val="111B2E"/>
+          </a:solidFill>
+          <a:ln w="12700">
+            <a:solidFill>
+              <a:srgbClr val="94A3B8"/>
+            </a:solidFill>
+          </a:ln>
+          <a:effectLst/>
+        </p:spPr>
+        <p:style>
+          <a:lnRef idx="1">
+            <a:schemeClr val="accent1"/>
+          </a:lnRef>
+          <a:fillRef idx="3">
+            <a:schemeClr val="accent1"/>
+          </a:fillRef>
+          <a:effectRef idx="2">
+            <a:schemeClr val="accent1"/>
+          </a:effectRef>
+          <a:fontRef idx="minor">
+            <a:schemeClr val="lt1"/>
+          </a:fontRef>
+        </p:style>
+        <p:txBody>
+          <a:bodyPr rtlCol="0" anchor="ctr" lIns="45720" rIns="45720" tIns="0" bIns="0"/>
+          <a:lstStyle/>
+          <a:p>
+            <a:pPr algn="ctr"/>
+            <a:r>
+              <a:rPr sz="1050" b="1">
+                <a:solidFill>
+                  <a:srgbClr val="94A3B8"/>
+                </a:solidFill>
+                <a:latin typeface="Calibri"/>
+              </a:rPr>
+              <a:t>scikit-learn</a:t>
+            </a:r>
+          </a:p>
+        </p:txBody>
+      </p:sp>
+      <p:sp>
+        <p:nvSpPr>
+          <p:cNvPr id="52" name="Rounded Rectangle 51"/>
+          <p:cNvSpPr/>
+          <p:nvPr/>
+        </p:nvSpPr>
+        <p:spPr>
+          <a:xfrm>
+            <a:off x="4265675" y="5760720"/>
+            <a:ext cx="1161288" cy="292608"/>
+          </a:xfrm>
+          <a:prstGeom prst="roundRect">
+            <a:avLst>
+              <a:gd name="adj" fmla="val 50000"/>
+            </a:avLst>
+          </a:prstGeom>
+          <a:solidFill>
+            <a:srgbClr val="111B2E"/>
+          </a:solidFill>
+          <a:ln w="12700">
+            <a:solidFill>
+              <a:srgbClr val="94A3B8"/>
+            </a:solidFill>
+          </a:ln>
+          <a:effectLst/>
+        </p:spPr>
+        <p:style>
+          <a:lnRef idx="1">
+            <a:schemeClr val="accent1"/>
+          </a:lnRef>
+          <a:fillRef idx="3">
+            <a:schemeClr val="accent1"/>
+          </a:fillRef>
+          <a:effectRef idx="2">
+            <a:schemeClr val="accent1"/>
+          </a:effectRef>
+          <a:fontRef idx="minor">
+            <a:schemeClr val="lt1"/>
+          </a:fontRef>
+        </p:style>
+        <p:txBody>
+          <a:bodyPr rtlCol="0" anchor="ctr" lIns="45720" rIns="45720" tIns="0" bIns="0"/>
+          <a:lstStyle/>
+          <a:p>
+            <a:pPr algn="ctr"/>
+            <a:r>
+              <a:rPr sz="1050" b="1">
+                <a:solidFill>
+                  <a:srgbClr val="94A3B8"/>
+                </a:solidFill>
+                <a:latin typeface="Calibri"/>
+              </a:rPr>
+              <a:t>VADER</a:t>
+            </a:r>
+          </a:p>
+        </p:txBody>
+      </p:sp>
+      <p:sp>
+        <p:nvSpPr>
+          <p:cNvPr id="53" name="Rounded Rectangle 52"/>
+          <p:cNvSpPr/>
+          <p:nvPr/>
+        </p:nvSpPr>
+        <p:spPr>
+          <a:xfrm>
+            <a:off x="5504688" y="5760720"/>
+            <a:ext cx="1161288" cy="292608"/>
+          </a:xfrm>
+          <a:prstGeom prst="roundRect">
+            <a:avLst>
+              <a:gd name="adj" fmla="val 50000"/>
+            </a:avLst>
+          </a:prstGeom>
+          <a:solidFill>
+            <a:srgbClr val="111B2E"/>
+          </a:solidFill>
+          <a:ln w="12700">
+            <a:solidFill>
+              <a:srgbClr val="94A3B8"/>
+            </a:solidFill>
+          </a:ln>
+          <a:effectLst/>
+        </p:spPr>
+        <p:style>
+          <a:lnRef idx="1">
+            <a:schemeClr val="accent1"/>
+          </a:lnRef>
+          <a:fillRef idx="3">
+            <a:schemeClr val="accent1"/>
+          </a:fillRef>
+          <a:effectRef idx="2">
+            <a:schemeClr val="accent1"/>
+          </a:effectRef>
+          <a:fontRef idx="minor">
+            <a:schemeClr val="lt1"/>
+          </a:fontRef>
+        </p:style>
+        <p:txBody>
+          <a:bodyPr rtlCol="0" anchor="ctr" lIns="45720" rIns="45720" tIns="0" bIns="0"/>
+          <a:lstStyle/>
+          <a:p>
+            <a:pPr algn="ctr"/>
+            <a:r>
+              <a:rPr sz="1050" b="1">
+                <a:solidFill>
+                  <a:srgbClr val="94A3B8"/>
+                </a:solidFill>
+                <a:latin typeface="Calibri"/>
+              </a:rPr>
+              <a:t>Pydantic</a:t>
+            </a:r>
+          </a:p>
+        </p:txBody>
+      </p:sp>
+      <p:sp>
+        <p:nvSpPr>
+          <p:cNvPr id="54" name="Rounded Rectangle 53"/>
+          <p:cNvSpPr/>
+          <p:nvPr/>
+        </p:nvSpPr>
+        <p:spPr>
+          <a:xfrm>
+            <a:off x="6743700" y="5760720"/>
+            <a:ext cx="1161288" cy="292608"/>
+          </a:xfrm>
+          <a:prstGeom prst="roundRect">
+            <a:avLst>
+              <a:gd name="adj" fmla="val 50000"/>
+            </a:avLst>
+          </a:prstGeom>
+          <a:solidFill>
+            <a:srgbClr val="111B2E"/>
+          </a:solidFill>
+          <a:ln w="12700">
+            <a:solidFill>
+              <a:srgbClr val="94A3B8"/>
+            </a:solidFill>
+          </a:ln>
+          <a:effectLst/>
+        </p:spPr>
+        <p:style>
+          <a:lnRef idx="1">
+            <a:schemeClr val="accent1"/>
+          </a:lnRef>
+          <a:fillRef idx="3">
+            <a:schemeClr val="accent1"/>
+          </a:fillRef>
+          <a:effectRef idx="2">
+            <a:schemeClr val="accent1"/>
+          </a:effectRef>
+          <a:fontRef idx="minor">
+            <a:schemeClr val="lt1"/>
+          </a:fontRef>
+        </p:style>
+        <p:txBody>
+          <a:bodyPr rtlCol="0" anchor="ctr" lIns="45720" rIns="45720" tIns="0" bIns="0"/>
+          <a:lstStyle/>
+          <a:p>
+            <a:pPr algn="ctr"/>
+            <a:r>
+              <a:rPr sz="1050" b="1">
+                <a:solidFill>
+                  <a:srgbClr val="94A3B8"/>
+                </a:solidFill>
+                <a:latin typeface="Calibri"/>
+              </a:rPr>
+              <a:t>FastAPI</a:t>
+            </a:r>
+          </a:p>
+        </p:txBody>
+      </p:sp>
+      <p:sp>
+        <p:nvSpPr>
+          <p:cNvPr id="55" name="Rounded Rectangle 54"/>
+          <p:cNvSpPr/>
+          <p:nvPr/>
+        </p:nvSpPr>
+        <p:spPr>
+          <a:xfrm>
+            <a:off x="7982711" y="5760720"/>
+            <a:ext cx="1161288" cy="292608"/>
+          </a:xfrm>
+          <a:prstGeom prst="roundRect">
+            <a:avLst>
+              <a:gd name="adj" fmla="val 50000"/>
+            </a:avLst>
+          </a:prstGeom>
+          <a:solidFill>
+            <a:srgbClr val="111B2E"/>
+          </a:solidFill>
+          <a:ln w="12700">
+            <a:solidFill>
+              <a:srgbClr val="94A3B8"/>
+            </a:solidFill>
+          </a:ln>
+          <a:effectLst/>
+        </p:spPr>
+        <p:style>
+          <a:lnRef idx="1">
+            <a:schemeClr val="accent1"/>
+          </a:lnRef>
+          <a:fillRef idx="3">
+            <a:schemeClr val="accent1"/>
+          </a:fillRef>
+          <a:effectRef idx="2">
+            <a:schemeClr val="accent1"/>
+          </a:effectRef>
+          <a:fontRef idx="minor">
+            <a:schemeClr val="lt1"/>
+          </a:fontRef>
+        </p:style>
+        <p:txBody>
+          <a:bodyPr rtlCol="0" anchor="ctr" lIns="45720" rIns="45720" tIns="0" bIns="0"/>
+          <a:lstStyle/>
+          <a:p>
+            <a:pPr algn="ctr"/>
+            <a:r>
+              <a:rPr sz="1050" b="1">
+                <a:solidFill>
+                  <a:srgbClr val="94A3B8"/>
+                </a:solidFill>
+                <a:latin typeface="Calibri"/>
+              </a:rPr>
+              <a:t>Streamlit</a:t>
+            </a:r>
+          </a:p>
+        </p:txBody>
+      </p:sp>
+      <p:sp>
+        <p:nvSpPr>
+          <p:cNvPr id="56" name="Rounded Rectangle 55"/>
+          <p:cNvSpPr/>
+          <p:nvPr/>
+        </p:nvSpPr>
+        <p:spPr>
+          <a:xfrm>
+            <a:off x="9221724" y="5760720"/>
+            <a:ext cx="1161288" cy="292608"/>
+          </a:xfrm>
+          <a:prstGeom prst="roundRect">
+            <a:avLst>
+              <a:gd name="adj" fmla="val 50000"/>
+            </a:avLst>
+          </a:prstGeom>
+          <a:solidFill>
+            <a:srgbClr val="111B2E"/>
+          </a:solidFill>
+          <a:ln w="12700">
+            <a:solidFill>
+              <a:srgbClr val="94A3B8"/>
+            </a:solidFill>
+          </a:ln>
+          <a:effectLst/>
+        </p:spPr>
+        <p:style>
+          <a:lnRef idx="1">
+            <a:schemeClr val="accent1"/>
+          </a:lnRef>
+          <a:fillRef idx="3">
+            <a:schemeClr val="accent1"/>
+          </a:fillRef>
+          <a:effectRef idx="2">
+            <a:schemeClr val="accent1"/>
+          </a:effectRef>
+          <a:fontRef idx="minor">
+            <a:schemeClr val="lt1"/>
+          </a:fontRef>
+        </p:style>
+        <p:txBody>
+          <a:bodyPr rtlCol="0" anchor="ctr" lIns="45720" rIns="45720" tIns="0" bIns="0"/>
+          <a:lstStyle/>
+          <a:p>
+            <a:pPr algn="ctr"/>
+            <a:r>
+              <a:rPr sz="1050" b="1">
+                <a:solidFill>
+                  <a:srgbClr val="94A3B8"/>
+                </a:solidFill>
+                <a:latin typeface="Calibri"/>
+              </a:rPr>
+              <a:t>Plotly</a:t>
+            </a:r>
+          </a:p>
+        </p:txBody>
+      </p:sp>
+      <p:sp>
+        <p:nvSpPr>
+          <p:cNvPr id="57" name="Rounded Rectangle 56"/>
+          <p:cNvSpPr/>
+          <p:nvPr/>
+        </p:nvSpPr>
+        <p:spPr>
+          <a:xfrm>
+            <a:off x="10460736" y="5760720"/>
+            <a:ext cx="1161288" cy="292608"/>
+          </a:xfrm>
+          <a:prstGeom prst="roundRect">
+            <a:avLst>
+              <a:gd name="adj" fmla="val 50000"/>
+            </a:avLst>
+          </a:prstGeom>
+          <a:solidFill>
+            <a:srgbClr val="111B2E"/>
+          </a:solidFill>
+          <a:ln w="12700">
+            <a:solidFill>
+              <a:srgbClr val="94A3B8"/>
+            </a:solidFill>
+          </a:ln>
+          <a:effectLst/>
+        </p:spPr>
+        <p:style>
+          <a:lnRef idx="1">
+            <a:schemeClr val="accent1"/>
+          </a:lnRef>
+          <a:fillRef idx="3">
+            <a:schemeClr val="accent1"/>
+          </a:fillRef>
+          <a:effectRef idx="2">
+            <a:schemeClr val="accent1"/>
+          </a:effectRef>
+          <a:fontRef idx="minor">
+            <a:schemeClr val="lt1"/>
+          </a:fontRef>
+        </p:style>
+        <p:txBody>
+          <a:bodyPr rtlCol="0" anchor="ctr" lIns="45720" rIns="45720" tIns="0" bIns="0"/>
+          <a:lstStyle/>
+          <a:p>
+            <a:pPr algn="ctr"/>
+            <a:r>
+              <a:rPr sz="1050" b="1">
+                <a:solidFill>
+                  <a:srgbClr val="94A3B8"/>
+                </a:solidFill>
+                <a:latin typeface="Calibri"/>
+              </a:rPr>
+              <a:t>pytest</a:t>
+            </a:r>
+          </a:p>
+        </p:txBody>
+      </p:sp>
+      <p:sp>
+        <p:nvSpPr>
+          <p:cNvPr id="58" name="TextBox 57"/>
+          <p:cNvSpPr txBox="1"/>
+          <p:nvPr/>
+        </p:nvSpPr>
+        <p:spPr>
+          <a:xfrm>
+            <a:off x="2788920" y="3931920"/>
+            <a:ext cx="2011680" cy="1097280"/>
+          </a:xfrm>
+          <a:prstGeom prst="rect">
+            <a:avLst/>
+          </a:prstGeom>
+          <a:noFill/>
+        </p:spPr>
+        <p:txBody>
+          <a:bodyPr wrap="square" lIns="0" rIns="0" tIns="0" bIns="0" anchor="t">
+            <a:spAutoFit/>
+          </a:bodyPr>
+          <a:lstStyle/>
+          <a:p>
+            <a:pPr algn="l">
+              <a:spcAft>
+                <a:spcPts val="400"/>
+              </a:spcAft>
+            </a:pPr>
+            <a:r>
+              <a:rPr sz="1100" b="0" i="1">
+                <a:solidFill>
+                  <a:srgbClr val="94A3B8"/>
+                </a:solidFill>
+                <a:latin typeface="Calibri"/>
+              </a:rPr>
+              <a:t>Dashboard, API, CLI and reports call the same modules, so shown and exported numbers always agree.</a:t>
             </a:r>
           </a:p>
         </p:txBody>
@@ -9248,7 +10863,7 @@
         </p:nvSpPr>
         <p:spPr>
           <a:xfrm>
-            <a:off x="6492240" y="4754880"/>
+            <a:off x="6492240" y="4681728"/>
             <a:ext cx="4937760" cy="274320"/>
           </a:xfrm>
           <a:prstGeom prst="rect">
@@ -9274,21 +10889,240 @@
                 </a:solidFill>
                 <a:latin typeface="Calibri"/>
               </a:rPr>
-              <a:t>Why impact = 9</a:t>
-            </a:r>
-          </a:p>
-        </p:txBody>
-      </p:sp>
-      <p:sp>
-        <p:nvSpPr>
-          <p:cNvPr id="36" name="TextBox 35"/>
+              <a:t>Why impact = 9  (raw 9.3, rounded)</a:t>
+            </a:r>
+          </a:p>
+        </p:txBody>
+      </p:sp>
+      <p:sp>
+        <p:nvSpPr>
+          <p:cNvPr id="36" name="Rectangle 35"/>
+          <p:cNvSpPr/>
+          <p:nvPr/>
+        </p:nvSpPr>
+        <p:spPr>
+          <a:xfrm>
+            <a:off x="6492240" y="5029200"/>
+            <a:ext cx="2971800" cy="274320"/>
+          </a:xfrm>
+          <a:prstGeom prst="rect">
+            <a:avLst/>
+          </a:prstGeom>
+          <a:solidFill>
+            <a:srgbClr val="3C5A99"/>
+          </a:solidFill>
+          <a:ln>
+            <a:solidFill>
+              <a:srgbClr val="18263B"/>
+            </a:solidFill>
+          </a:ln>
+          <a:effectLst/>
+        </p:spPr>
+        <p:style>
+          <a:lnRef idx="1">
+            <a:schemeClr val="accent1"/>
+          </a:lnRef>
+          <a:fillRef idx="3">
+            <a:schemeClr val="accent1"/>
+          </a:fillRef>
+          <a:effectRef idx="2">
+            <a:schemeClr val="accent1"/>
+          </a:effectRef>
+          <a:fontRef idx="minor">
+            <a:schemeClr val="lt1"/>
+          </a:fontRef>
+        </p:style>
+        <p:txBody>
+          <a:bodyPr rtlCol="0" anchor="ctr"/>
+          <a:lstStyle/>
+          <a:p>
+            <a:pPr algn="ctr"/>
+          </a:p>
+        </p:txBody>
+      </p:sp>
+      <p:sp>
+        <p:nvSpPr>
+          <p:cNvPr id="37" name="Rectangle 36"/>
+          <p:cNvSpPr/>
+          <p:nvPr/>
+        </p:nvSpPr>
+        <p:spPr>
+          <a:xfrm>
+            <a:off x="9464040" y="5029200"/>
+            <a:ext cx="228600" cy="274320"/>
+          </a:xfrm>
+          <a:prstGeom prst="rect">
+            <a:avLst/>
+          </a:prstGeom>
+          <a:solidFill>
+            <a:srgbClr val="F4B942"/>
+          </a:solidFill>
+          <a:ln>
+            <a:solidFill>
+              <a:srgbClr val="18263B"/>
+            </a:solidFill>
+          </a:ln>
+          <a:effectLst/>
+        </p:spPr>
+        <p:style>
+          <a:lnRef idx="1">
+            <a:schemeClr val="accent1"/>
+          </a:lnRef>
+          <a:fillRef idx="3">
+            <a:schemeClr val="accent1"/>
+          </a:fillRef>
+          <a:effectRef idx="2">
+            <a:schemeClr val="accent1"/>
+          </a:effectRef>
+          <a:fontRef idx="minor">
+            <a:schemeClr val="lt1"/>
+          </a:fontRef>
+        </p:style>
+        <p:txBody>
+          <a:bodyPr rtlCol="0" anchor="ctr"/>
+          <a:lstStyle/>
+          <a:p>
+            <a:pPr algn="ctr"/>
+          </a:p>
+        </p:txBody>
+      </p:sp>
+      <p:sp>
+        <p:nvSpPr>
+          <p:cNvPr id="38" name="Rectangle 37"/>
+          <p:cNvSpPr/>
+          <p:nvPr/>
+        </p:nvSpPr>
+        <p:spPr>
+          <a:xfrm>
+            <a:off x="9692640" y="5029200"/>
+            <a:ext cx="382676" cy="274320"/>
+          </a:xfrm>
+          <a:prstGeom prst="rect">
+            <a:avLst/>
+          </a:prstGeom>
+          <a:solidFill>
+            <a:srgbClr val="18A999"/>
+          </a:solidFill>
+          <a:ln>
+            <a:solidFill>
+              <a:srgbClr val="18263B"/>
+            </a:solidFill>
+          </a:ln>
+          <a:effectLst/>
+        </p:spPr>
+        <p:style>
+          <a:lnRef idx="1">
+            <a:schemeClr val="accent1"/>
+          </a:lnRef>
+          <a:fillRef idx="3">
+            <a:schemeClr val="accent1"/>
+          </a:fillRef>
+          <a:effectRef idx="2">
+            <a:schemeClr val="accent1"/>
+          </a:effectRef>
+          <a:fontRef idx="minor">
+            <a:schemeClr val="lt1"/>
+          </a:fontRef>
+        </p:style>
+        <p:txBody>
+          <a:bodyPr rtlCol="0" anchor="ctr"/>
+          <a:lstStyle/>
+          <a:p>
+            <a:pPr algn="ctr"/>
+          </a:p>
+        </p:txBody>
+      </p:sp>
+      <p:sp>
+        <p:nvSpPr>
+          <p:cNvPr id="39" name="Rectangle 38"/>
+          <p:cNvSpPr/>
+          <p:nvPr/>
+        </p:nvSpPr>
+        <p:spPr>
+          <a:xfrm>
+            <a:off x="10075316" y="5029200"/>
+            <a:ext cx="685800" cy="274320"/>
+          </a:xfrm>
+          <a:prstGeom prst="rect">
+            <a:avLst/>
+          </a:prstGeom>
+          <a:solidFill>
+            <a:srgbClr val="F05260"/>
+          </a:solidFill>
+          <a:ln>
+            <a:solidFill>
+              <a:srgbClr val="18263B"/>
+            </a:solidFill>
+          </a:ln>
+          <a:effectLst/>
+        </p:spPr>
+        <p:style>
+          <a:lnRef idx="1">
+            <a:schemeClr val="accent1"/>
+          </a:lnRef>
+          <a:fillRef idx="3">
+            <a:schemeClr val="accent1"/>
+          </a:fillRef>
+          <a:effectRef idx="2">
+            <a:schemeClr val="accent1"/>
+          </a:effectRef>
+          <a:fontRef idx="minor">
+            <a:schemeClr val="lt1"/>
+          </a:fontRef>
+        </p:style>
+        <p:txBody>
+          <a:bodyPr rtlCol="0" anchor="ctr"/>
+          <a:lstStyle/>
+          <a:p>
+            <a:pPr algn="ctr"/>
+          </a:p>
+        </p:txBody>
+      </p:sp>
+      <p:cxnSp>
+        <p:nvCxnSpPr>
+          <p:cNvPr id="40" name="Connector 39"/>
+          <p:cNvCxnSpPr/>
+          <p:nvPr/>
+        </p:nvCxnSpPr>
+        <p:spPr>
+          <a:xfrm>
+            <a:off x="9692640" y="4956048"/>
+            <a:ext cx="0" cy="420624"/>
+          </a:xfrm>
+          <a:prstGeom prst="line">
+            <a:avLst/>
+          </a:prstGeom>
+          <a:ln w="22225">
+            <a:solidFill>
+              <a:srgbClr val="F4B942"/>
+            </a:solidFill>
+          </a:ln>
+        </p:spPr>
+        <p:style>
+          <a:lnRef idx="2">
+            <a:schemeClr val="accent1"/>
+          </a:lnRef>
+          <a:fillRef idx="0">
+            <a:schemeClr val="accent1"/>
+          </a:fillRef>
+          <a:effectRef idx="1">
+            <a:schemeClr val="accent1"/>
+          </a:effectRef>
+          <a:fontRef idx="minor">
+            <a:schemeClr val="tx1"/>
+          </a:fontRef>
+        </p:style>
+      </p:cxnSp>
+      <p:sp>
+        <p:nvSpPr>
+          <p:cNvPr id="41" name="TextBox 40"/>
           <p:cNvSpPr txBox="1"/>
           <p:nvPr/>
         </p:nvSpPr>
         <p:spPr>
           <a:xfrm>
-            <a:off x="6492240" y="5029200"/>
-            <a:ext cx="4937760" cy="548640"/>
+            <a:off x="6492240" y="5413248"/>
+            <a:ext cx="5029200" cy="274320"/>
           </a:xfrm>
           <a:prstGeom prst="rect">
             <a:avLst/>
@@ -9307,27 +11141,72 @@
               </a:spcAft>
             </a:pPr>
             <a:r>
-              <a:rPr sz="1200" b="0" i="0">
-                <a:solidFill>
-                  <a:srgbClr val="94A3B8"/>
-                </a:solidFill>
-                <a:latin typeface="Calibri"/>
-              </a:rPr>
-              <a:t>base 6.5 + intensity 0.5 + exposure 0.8 + tone 1.5 = 9.3 -&gt; rounded 9</a:t>
-            </a:r>
-          </a:p>
-        </p:txBody>
-      </p:sp>
-      <p:sp>
-        <p:nvSpPr>
-          <p:cNvPr id="37" name="TextBox 36"/>
+              <a:rPr sz="1100" b="1" i="0">
+                <a:solidFill>
+                  <a:srgbClr val="7FA0E6"/>
+                </a:solidFill>
+                <a:latin typeface="Calibri"/>
+              </a:rPr>
+              <a:t>base 6.5</a:t>
+            </a:r>
+            <a:r>
+              <a:rPr sz="1100" b="1" i="0">
+                <a:solidFill>
+                  <a:srgbClr val="F4B942"/>
+                </a:solidFill>
+                <a:latin typeface="Calibri"/>
+              </a:rPr>
+              <a:t>  +  intensity 0.5</a:t>
+            </a:r>
+            <a:r>
+              <a:rPr sz="1100" b="1" i="0">
+                <a:solidFill>
+                  <a:srgbClr val="18A999"/>
+                </a:solidFill>
+                <a:latin typeface="Calibri"/>
+              </a:rPr>
+              <a:t>  +  exposure 0.8</a:t>
+            </a:r>
+            <a:r>
+              <a:rPr sz="1100" b="1" i="0">
+                <a:solidFill>
+                  <a:srgbClr val="F05260"/>
+                </a:solidFill>
+                <a:latin typeface="Calibri"/>
+              </a:rPr>
+              <a:t>  +  tone 1.5</a:t>
+            </a:r>
+            <a:r>
+              <a:rPr sz="1100" b="1" i="0">
+                <a:solidFill>
+                  <a:srgbClr val="F3F6FC"/>
+                </a:solidFill>
+                <a:latin typeface="Calibri"/>
+              </a:rPr>
+              <a:t>  =  9.3</a:t>
+            </a:r>
+            <a:r>
+              <a:rPr sz="1000" b="0" i="0">
+                <a:solidFill>
+                  <a:srgbClr val="F4B942"/>
+                </a:solidFill>
+                <a:latin typeface="Calibri"/>
+              </a:rPr>
+              <a:t>     | marker = trigger &gt; 7</a:t>
+            </a:r>
+          </a:p>
+        </p:txBody>
+      </p:sp>
+      <p:sp>
+        <p:nvSpPr>
+          <p:cNvPr id="42" name="TextBox 41"/>
           <p:cNvSpPr txBox="1"/>
           <p:nvPr/>
         </p:nvSpPr>
         <p:spPr>
           <a:xfrm>
-            <a:off x="6492240" y="5486400"/>
-            <a:ext cx="4937760" cy="502920"/>
+            <a:off x="6492240" y="5760720"/>
+            <a:ext cx="4937760" cy="274320"/>
           </a:xfrm>
           <a:prstGeom prst="rect">
             <a:avLst/>
@@ -9352,7 +11231,7 @@
                 </a:solidFill>
                 <a:latin typeface="Calibri"/>
               </a:rPr>
-              <a:t>Keywords: default, downgrad, missed a coupon, restructur</a:t>
+              <a:t>Keywords: default, downgrades, missed a coupon, restructuring</a:t>
             </a:r>
           </a:p>
         </p:txBody>
@@ -10243,7 +12122,7 @@
                 </a:solidFill>
                 <a:latin typeface="Calibri"/>
               </a:rPr>
-              <a:t>•  Spreads +125 bp BBB / +312 bp HY</a:t>
+              <a:t>•  Spreads +125 bp BBB / +312.5 bp HY</a:t>
             </a:r>
           </a:p>
           <a:p>
@@ -11141,7 +13020,7 @@
                 </a:solidFill>
                 <a:latin typeface="Calibri"/>
               </a:rPr>
-              <a:t>P&amp;L RECONCILIATION GAP</a:t>
+              <a:t>TEXT -&gt; SIGNALS</a:t>
             </a:r>
           </a:p>
         </p:txBody>
@@ -11176,11 +13055,11 @@
             <a:r>
               <a:rPr sz="2600" b="1" i="0">
                 <a:solidFill>
-                  <a:srgbClr val="22C55E"/>
-                </a:solidFill>
-                <a:latin typeface="Calibri"/>
-              </a:rPr>
-              <a:t>0.00</a:t>
+                  <a:srgbClr val="4F7CFF"/>
+                </a:solidFill>
+                <a:latin typeface="Calibri"/>
+              </a:rPr>
+              <a:t>0.5 s</a:t>
             </a:r>
           </a:p>
         </p:txBody>
@@ -11219,7 +13098,7 @@
                 </a:solidFill>
                 <a:latin typeface="Calibri"/>
               </a:rPr>
-              <a:t>components = positions = total</a:t>
+              <a:t>254 records, laptop CPU</a:t>
             </a:r>
           </a:p>
         </p:txBody>
@@ -11354,7 +13233,7 @@
         <p:spPr>
           <a:xfrm>
             <a:off x="9555480" y="1965960"/>
-            <a:ext cx="1920240" cy="3931920"/>
+            <a:ext cx="1920240" cy="2743200"/>
           </a:xfrm>
           <a:prstGeom prst="rect">
             <a:avLst/>
@@ -11435,6 +13314,84 @@
       <p:sp>
         <p:nvSpPr>
           <p:cNvPr id="27" name="TextBox 26"/>
+          <p:cNvSpPr txBox="1"/>
+          <p:nvPr/>
+        </p:nvSpPr>
+        <p:spPr>
+          <a:xfrm>
+            <a:off x="9555480" y="4572000"/>
+            <a:ext cx="1920240" cy="548640"/>
+          </a:xfrm>
+          <a:prstGeom prst="rect">
+            <a:avLst/>
+          </a:prstGeom>
+          <a:noFill/>
+        </p:spPr>
+        <p:txBody>
+          <a:bodyPr wrap="square" lIns="0" rIns="0" tIns="0" bIns="0" anchor="t">
+            <a:spAutoFit/>
+          </a:bodyPr>
+          <a:lstStyle/>
+          <a:p>
+            <a:pPr algn="l">
+              <a:spcAft>
+                <a:spcPts val="400"/>
+              </a:spcAft>
+            </a:pPr>
+            <a:r>
+              <a:rPr sz="3400" b="1" i="0">
+                <a:solidFill>
+                  <a:srgbClr val="F05260"/>
+                </a:solidFill>
+                <a:latin typeface="Calibri"/>
+              </a:rPr>
+              <a:t>22%</a:t>
+            </a:r>
+          </a:p>
+        </p:txBody>
+      </p:sp>
+      <p:sp>
+        <p:nvSpPr>
+          <p:cNvPr id="28" name="TextBox 27"/>
+          <p:cNvSpPr txBox="1"/>
+          <p:nvPr/>
+        </p:nvSpPr>
+        <p:spPr>
+          <a:xfrm>
+            <a:off x="9555480" y="5166360"/>
+            <a:ext cx="1920240" cy="822960"/>
+          </a:xfrm>
+          <a:prstGeom prst="rect">
+            <a:avLst/>
+          </a:prstGeom>
+          <a:noFill/>
+        </p:spPr>
+        <p:txBody>
+          <a:bodyPr wrap="square" lIns="0" rIns="0" tIns="0" bIns="0" anchor="t">
+            <a:spAutoFit/>
+          </a:bodyPr>
+          <a:lstStyle/>
+          <a:p>
+            <a:pPr algn="l">
+              <a:spcAft>
+                <a:spcPts val="400"/>
+              </a:spcAft>
+            </a:pPr>
+            <a:r>
+              <a:rPr sz="1100" b="0" i="0">
+                <a:solidFill>
+                  <a:srgbClr val="94A3B8"/>
+                </a:solidFill>
+                <a:latin typeface="Calibri"/>
+              </a:rPr>
+              <a:t>of signals (56 of 254) exceed the trigger - analysts review these first</a:t>
+            </a:r>
+          </a:p>
+        </p:txBody>
+      </p:sp>
+      <p:sp>
+        <p:nvSpPr>
+          <p:cNvPr id="29" name="TextBox 28"/>
           <p:cNvSpPr txBox="1"/>
           <p:nvPr/>
         </p:nvSpPr>

</xml_diff>